<commit_message>
Updated my Readme to add my ERD and updated my pitchdeck
</commit_message>
<xml_diff>
--- a/Superstore_Performance_Fulfillment_Analytics.pptx
+++ b/Superstore_Performance_Fulfillment_Analytics.pptx
@@ -5,15 +5,16 @@
     <p:sldMasterId id="2147483648" r:id="rId1"/>
   </p:sldMasterIdLst>
   <p:notesMasterIdLst>
-    <p:notesMasterId r:id="rId8"/>
+    <p:notesMasterId r:id="rId9"/>
   </p:notesMasterIdLst>
   <p:sldIdLst>
     <p:sldId id="256" r:id="rId2"/>
     <p:sldId id="257" r:id="rId3"/>
     <p:sldId id="258" r:id="rId4"/>
-    <p:sldId id="260" r:id="rId5"/>
-    <p:sldId id="261" r:id="rId6"/>
-    <p:sldId id="262" r:id="rId7"/>
+    <p:sldId id="259" r:id="rId5"/>
+    <p:sldId id="260" r:id="rId6"/>
+    <p:sldId id="261" r:id="rId7"/>
+    <p:sldId id="262" r:id="rId8"/>
   </p:sldIdLst>
   <p:sldSz cx="12192000" cy="6858000"/>
   <p:notesSz cx="6858000" cy="12192000"/>
@@ -112,20 +113,21 @@
   <p:extLst>
     <p:ext uri="{521415D9-36F7-43E2-AB2F-B90AF26B5E84}">
       <p14:sectionLst xmlns:p14="http://schemas.microsoft.com/office/powerpoint/2010/main">
-        <p14:section name="Overview" id="{9E453B1D-DC42-E343-DB83-8B215EA37310}">
+        <p14:section name="Overview" id="{C9F201A2-50E6-7988-1513-AC466B1A3922}">
           <p14:sldIdLst>
             <p14:sldId id="256"/>
             <p14:sldId id="257"/>
           </p14:sldIdLst>
         </p14:section>
-        <p14:section name="Analysis" id="{E0FAA7D1-3181-0934-6614-9B91080A644B}">
+        <p14:section name="Analysis" id="{009ED4BA-72D9-BDB3-5C4B-743C4A8ED75B}">
           <p14:sldIdLst>
             <p14:sldId id="258"/>
+            <p14:sldId id="259"/>
             <p14:sldId id="260"/>
             <p14:sldId id="261"/>
           </p14:sldIdLst>
         </p14:section>
-        <p14:section name="Next Steps" id="{12CB6EF7-5F96-B3CC-3104-FC2020019BF1}">
+        <p14:section name="Next Steps" id="{5924BEDA-ECAB-0D08-EB45-863F2ACE1801}">
           <p14:sldIdLst>
             <p14:sldId id="262"/>
           </p14:sldIdLst>
@@ -137,6 +139,331 @@
     </p:ext>
   </p:extLst>
 </p:presentation>
+</file>
+
+<file path=ppt/charts/chart1.xml><?xml version="1.0" encoding="utf-8"?>
+<c:chartSpace xmlns:c="http://schemas.openxmlformats.org/drawingml/2006/chart" xmlns:a="http://schemas.openxmlformats.org/drawingml/2006/main" xmlns:r="http://schemas.openxmlformats.org/officeDocument/2006/relationships" xmlns:c16r2="http://schemas.microsoft.com/office/drawing/2015/06/chart">
+  <c:date1904 val="0"/>
+  <c:lang val="en-US"/>
+  <c:roundedCorners val="1"/>
+  <c:style val="2"/>
+  <c:chart>
+    <c:title>
+      <c:tx>
+        <c:rich>
+          <a:bodyPr/>
+          <a:lstStyle/>
+          <a:p>
+            <a:pPr>
+              <a:defRPr sz="1400" b="0" i="0" u="none" strike="noStrike">
+                <a:solidFill>
+                  <a:srgbClr val="1B2A4A"/>
+                </a:solidFill>
+                <a:latin typeface="+mn-lt"/>
+              </a:defRPr>
+            </a:pPr>
+            <a:r>
+              <a:rPr lang="en-US" sz="1400" b="0" i="0" u="none" strike="noStrike">
+                <a:solidFill>
+                  <a:srgbClr val="1B2A4A"/>
+                </a:solidFill>
+                <a:latin typeface="+mn-lt"/>
+              </a:rPr>
+              <a:t>Sales by market region ($M)</a:t>
+            </a:r>
+          </a:p>
+        </c:rich>
+      </c:tx>
+      <c:overlay val="0"/>
+    </c:title>
+    <c:autoTitleDeleted val="0"/>
+    <c:plotArea>
+      <c:layout/>
+      <c:barChart>
+        <c:barDir val="bar"/>
+        <c:grouping val="clustered"/>
+        <c:varyColors val="0"/>
+        <c:ser>
+          <c:idx val="0"/>
+          <c:order val="0"/>
+          <c:tx>
+            <c:strRef>
+              <c:f>Sheet1!$B$1</c:f>
+              <c:strCache>
+                <c:ptCount val="1"/>
+                <c:pt idx="0">
+                  <c:v>Sales ($M)</c:v>
+                </c:pt>
+              </c:strCache>
+            </c:strRef>
+          </c:tx>
+          <c:spPr>
+            <a:solidFill>
+              <a:srgbClr val="1B2A4A"/>
+            </a:solidFill>
+            <a:effectLst/>
+          </c:spPr>
+          <c:invertIfNegative val="0"/>
+          <c:dLbls>
+            <c:numFmt formatCode="0.00" sourceLinked="0"/>
+            <c:spPr>
+              <a:noFill/>
+              <a:ln>
+                <a:noFill/>
+              </a:ln>
+              <a:effectLst/>
+            </c:spPr>
+            <c:txPr>
+              <a:bodyPr/>
+              <a:lstStyle/>
+              <a:p>
+                <a:pPr>
+                  <a:defRPr sz="1000" b="0" i="0" u="none" strike="noStrike">
+                    <a:solidFill>
+                      <a:srgbClr val="4A5568"/>
+                    </a:solidFill>
+                    <a:latin typeface="+mn-lt"/>
+                  </a:defRPr>
+                </a:pPr>
+                <a:endParaRPr lang="en-NG"/>
+              </a:p>
+            </c:txPr>
+            <c:showLegendKey val="0"/>
+            <c:showVal val="1"/>
+            <c:showCatName val="0"/>
+            <c:showSerName val="0"/>
+            <c:showPercent val="0"/>
+            <c:showBubbleSize val="0"/>
+            <c:showLeaderLines val="0"/>
+            <c:extLst>
+              <c:ext xmlns:c15="http://schemas.microsoft.com/office/drawing/2012/chart" uri="{CE6537A1-D6FC-4f65-9D91-7224C49458BB}">
+                <c15:showLeaderLines val="0"/>
+              </c:ext>
+            </c:extLst>
+          </c:dLbls>
+          <c:cat>
+            <c:strRef>
+              <c:f>Sheet1!$A$2:$A$19</c:f>
+              <c:strCache>
+                <c:ptCount val="18"/>
+                <c:pt idx="0">
+                  <c:v>EU - Central</c:v>
+                </c:pt>
+                <c:pt idx="1">
+                  <c:v>APAC - Oceania</c:v>
+                </c:pt>
+                <c:pt idx="2">
+                  <c:v>APAC - Southeast Asia</c:v>
+                </c:pt>
+                <c:pt idx="3">
+                  <c:v>EMEA</c:v>
+                </c:pt>
+                <c:pt idx="4">
+                  <c:v>US - East</c:v>
+                </c:pt>
+                <c:pt idx="5">
+                  <c:v>US - West</c:v>
+                </c:pt>
+                <c:pt idx="6">
+                  <c:v>Africa</c:v>
+                </c:pt>
+                <c:pt idx="7">
+                  <c:v>LATAM - North</c:v>
+                </c:pt>
+                <c:pt idx="8">
+                  <c:v>LATAM - South</c:v>
+                </c:pt>
+                <c:pt idx="9">
+                  <c:v>LATAM - Central</c:v>
+                </c:pt>
+                <c:pt idx="10">
+                  <c:v>US - Central</c:v>
+                </c:pt>
+                <c:pt idx="11">
+                  <c:v>EU - North</c:v>
+                </c:pt>
+                <c:pt idx="12">
+                  <c:v>EU - South</c:v>
+                </c:pt>
+                <c:pt idx="13">
+                  <c:v>US - South</c:v>
+                </c:pt>
+                <c:pt idx="14">
+                  <c:v>APAC - North Asia</c:v>
+                </c:pt>
+                <c:pt idx="15">
+                  <c:v>APAC - Central Asia</c:v>
+                </c:pt>
+                <c:pt idx="16">
+                  <c:v>LATAM - Caribbean</c:v>
+                </c:pt>
+                <c:pt idx="17">
+                  <c:v>Canada</c:v>
+                </c:pt>
+              </c:strCache>
+            </c:strRef>
+          </c:cat>
+          <c:val>
+            <c:numRef>
+              <c:f>Sheet1!$B$2:$B$19</c:f>
+              <c:numCache>
+                <c:formatCode>General</c:formatCode>
+                <c:ptCount val="18"/>
+                <c:pt idx="0">
+                  <c:v>1.76</c:v>
+                </c:pt>
+                <c:pt idx="1">
+                  <c:v>0.99</c:v>
+                </c:pt>
+                <c:pt idx="2">
+                  <c:v>0.91</c:v>
+                </c:pt>
+                <c:pt idx="3">
+                  <c:v>0.85</c:v>
+                </c:pt>
+                <c:pt idx="4">
+                  <c:v>0.83</c:v>
+                </c:pt>
+                <c:pt idx="5">
+                  <c:v>0.83</c:v>
+                </c:pt>
+                <c:pt idx="6">
+                  <c:v>0.75</c:v>
+                </c:pt>
+                <c:pt idx="7">
+                  <c:v>0.72</c:v>
+                </c:pt>
+                <c:pt idx="8">
+                  <c:v>0.66</c:v>
+                </c:pt>
+                <c:pt idx="9">
+                  <c:v>0.65</c:v>
+                </c:pt>
+                <c:pt idx="10">
+                  <c:v>0.65</c:v>
+                </c:pt>
+                <c:pt idx="11">
+                  <c:v>0.65</c:v>
+                </c:pt>
+                <c:pt idx="12">
+                  <c:v>0.59</c:v>
+                </c:pt>
+                <c:pt idx="13">
+                  <c:v>0.51</c:v>
+                </c:pt>
+                <c:pt idx="14">
+                  <c:v>0.48</c:v>
+                </c:pt>
+                <c:pt idx="15">
+                  <c:v>0.39</c:v>
+                </c:pt>
+                <c:pt idx="16">
+                  <c:v>0.35</c:v>
+                </c:pt>
+                <c:pt idx="17">
+                  <c:v>0.06</c:v>
+                </c:pt>
+              </c:numCache>
+            </c:numRef>
+          </c:val>
+          <c:extLst>
+            <c:ext xmlns:c16="http://schemas.microsoft.com/office/drawing/2014/chart" uri="{C3380CC4-5D6E-409C-BE32-E72D297353CC}">
+              <c16:uniqueId val="{00000000-6E38-4003-9DE5-D3A0E446368A}"/>
+            </c:ext>
+          </c:extLst>
+        </c:ser>
+        <c:dLbls>
+          <c:showLegendKey val="0"/>
+          <c:showVal val="1"/>
+          <c:showCatName val="0"/>
+          <c:showSerName val="0"/>
+          <c:showPercent val="0"/>
+          <c:showBubbleSize val="0"/>
+        </c:dLbls>
+        <c:gapWidth val="35"/>
+        <c:axId val="2094734554"/>
+        <c:axId val="2094734552"/>
+      </c:barChart>
+      <c:catAx>
+        <c:axId val="2094734554"/>
+        <c:scaling>
+          <c:orientation val="maxMin"/>
+        </c:scaling>
+        <c:delete val="0"/>
+        <c:axPos val="l"/>
+        <c:numFmt formatCode="General" sourceLinked="1"/>
+        <c:majorTickMark val="out"/>
+        <c:minorTickMark val="none"/>
+        <c:tickLblPos val="nextTo"/>
+        <c:spPr>
+          <a:ln w="12700" cap="flat">
+            <a:solidFill>
+              <a:srgbClr val="888888"/>
+            </a:solidFill>
+            <a:prstDash val="solid"/>
+            <a:round/>
+          </a:ln>
+        </c:spPr>
+        <c:txPr>
+          <a:bodyPr/>
+          <a:lstStyle/>
+          <a:p>
+            <a:pPr>
+              <a:defRPr sz="1000" b="0" i="0" u="none" strike="noStrike">
+                <a:solidFill>
+                  <a:srgbClr val="4A5568"/>
+                </a:solidFill>
+                <a:latin typeface="+mn-lt"/>
+              </a:defRPr>
+            </a:pPr>
+            <a:endParaRPr lang="en-NG"/>
+          </a:p>
+        </c:txPr>
+        <c:crossAx val="2094734552"/>
+        <c:crosses val="autoZero"/>
+        <c:auto val="1"/>
+        <c:lblAlgn val="ctr"/>
+        <c:lblOffset val="100"/>
+        <c:noMultiLvlLbl val="1"/>
+      </c:catAx>
+      <c:valAx>
+        <c:axId val="2094734552"/>
+        <c:scaling>
+          <c:orientation val="minMax"/>
+        </c:scaling>
+        <c:delete val="1"/>
+        <c:axPos val="t"/>
+        <c:numFmt formatCode="General" sourceLinked="0"/>
+        <c:majorTickMark val="out"/>
+        <c:minorTickMark val="none"/>
+        <c:tickLblPos val="low"/>
+        <c:crossAx val="2094734554"/>
+        <c:crosses val="autoZero"/>
+        <c:crossBetween val="between"/>
+      </c:valAx>
+      <c:spPr>
+        <a:noFill/>
+        <a:ln>
+          <a:noFill/>
+        </a:ln>
+        <a:effectLst/>
+      </c:spPr>
+    </c:plotArea>
+    <c:plotVisOnly val="1"/>
+    <c:dispBlanksAs val="span"/>
+    <c:showDLblsOverMax val="1"/>
+  </c:chart>
+  <c:spPr>
+    <a:noFill/>
+    <a:ln>
+      <a:noFill/>
+    </a:ln>
+    <a:effectLst/>
+  </c:spPr>
+  <c:externalData r:id="rId1">
+    <c:autoUpdate val="0"/>
+  </c:externalData>
+</c:chartSpace>
 </file>
 
 <file path=ppt/notesMasters/notesMaster1.xml><?xml version="1.0" encoding="utf-8"?>
@@ -164,7 +491,7 @@
     </p:spTree>
     <p:extLst>
       <p:ext uri="{BB962C8B-B14F-4D97-AF65-F5344CB8AC3E}">
-        <p14:creationId xmlns:p14="http://schemas.microsoft.com/office/powerpoint/2010/main" val="3861855941"/>
+        <p14:creationId xmlns:p14="http://schemas.microsoft.com/office/powerpoint/2010/main" val="3622462009"/>
       </p:ext>
     </p:extLst>
   </p:cSld>
@@ -569,7 +896,10 @@
           <a:bodyPr/>
           <a:lstStyle/>
           <a:p>
-            <a:endParaRPr lang="en-US" dirty="0"/>
+            <a:r>
+              <a:rPr lang="en-US" dirty="0"/>
+              <a:t>Market-region view; EU, US, APAC and LATAM each combine their sub-regions. State-level detail was not part of the extract provided.</a:t>
+            </a:r>
           </a:p>
         </p:txBody>
       </p:sp>
@@ -759,6 +1089,90 @@
             <a:fld id="{F7021451-1387-4CA6-816F-3879F97B5CBC}" type="slidenum">
               <a:rPr lang="en-US"/>
               <a:t>6</a:t>
+            </a:fld>
+            <a:endParaRPr lang="en-US"/>
+          </a:p>
+        </p:txBody>
+      </p:sp>
+    </p:spTree>
+    <p:extLst>
+      <p:ext uri="{BB962C8B-B14F-4D97-AF65-F5344CB8AC3E}">
+        <p14:creationId xmlns:p14="http://schemas.microsoft.com/office/powerpoint/2010/main" val="1024086991"/>
+      </p:ext>
+    </p:extLst>
+  </p:cSld>
+  <p:clrMapOvr>
+    <a:masterClrMapping/>
+  </p:clrMapOvr>
+</p:notes>
+</file>
+
+<file path=ppt/notesSlides/notesSlide7.xml><?xml version="1.0" encoding="utf-8"?>
+<p:notes xmlns:a="http://schemas.openxmlformats.org/drawingml/2006/main" xmlns:r="http://schemas.openxmlformats.org/officeDocument/2006/relationships" xmlns:p="http://schemas.openxmlformats.org/presentationml/2006/main">
+  <p:cSld>
+    <p:spTree>
+      <p:nvGrpSpPr>
+        <p:cNvPr id="1" name=""/>
+        <p:cNvGrpSpPr/>
+        <p:nvPr/>
+      </p:nvGrpSpPr>
+      <p:grpSpPr>
+        <a:xfrm>
+          <a:off x="0" y="0"/>
+          <a:ext cx="0" cy="0"/>
+          <a:chOff x="0" y="0"/>
+          <a:chExt cx="0" cy="0"/>
+        </a:xfrm>
+      </p:grpSpPr>
+      <p:sp>
+        <p:nvSpPr>
+          <p:cNvPr id="2" name="Slide Image Placeholder 1"/>
+          <p:cNvSpPr>
+            <a:spLocks noGrp="1" noRot="1" noChangeAspect="1"/>
+          </p:cNvSpPr>
+          <p:nvPr>
+            <p:ph type="sldImg"/>
+          </p:nvPr>
+        </p:nvSpPr>
+        <p:spPr/>
+      </p:sp>
+      <p:sp>
+        <p:nvSpPr>
+          <p:cNvPr id="3" name="Notes Placeholder 2"/>
+          <p:cNvSpPr>
+            <a:spLocks noGrp="1"/>
+          </p:cNvSpPr>
+          <p:nvPr>
+            <p:ph type="body" idx="1"/>
+          </p:nvPr>
+        </p:nvSpPr>
+        <p:spPr/>
+        <p:txBody>
+          <a:bodyPr/>
+          <a:lstStyle/>
+          <a:p>
+            <a:endParaRPr lang="en-US" dirty="0"/>
+          </a:p>
+        </p:txBody>
+      </p:sp>
+      <p:sp>
+        <p:nvSpPr>
+          <p:cNvPr id="4" name="Slide Number Placeholder 3"/>
+          <p:cNvSpPr>
+            <a:spLocks noGrp="1"/>
+          </p:cNvSpPr>
+          <p:nvPr>
+            <p:ph type="sldNum" sz="quarter" idx="10"/>
+          </p:nvPr>
+        </p:nvSpPr>
+        <p:spPr/>
+        <p:txBody>
+          <a:bodyPr/>
+          <a:lstStyle/>
+          <a:p>
+            <a:fld id="{F7021451-1387-4CA6-816F-3879F97B5CBC}" type="slidenum">
+              <a:rPr lang="en-US"/>
+              <a:t>7</a:t>
             </a:fld>
             <a:endParaRPr lang="en-US"/>
           </a:p>
@@ -1740,592 +2154,12 @@
           </a:p>
         </p:txBody>
       </p:sp>
-      <p:sp>
-        <p:nvSpPr>
-          <p:cNvPr id="4" name="KPI TOTAL ORDERS"/>
-          <p:cNvSpPr/>
-          <p:nvPr/>
-        </p:nvSpPr>
-        <p:spPr>
-          <a:xfrm>
-            <a:off x="548640" y="1691640"/>
-            <a:ext cx="2567178" cy="2148840"/>
-          </a:xfrm>
-          <a:prstGeom prst="roundRect">
-            <a:avLst>
-              <a:gd name="adj" fmla="val 4255"/>
-            </a:avLst>
-          </a:prstGeom>
-          <a:solidFill>
-            <a:schemeClr val="bg2"/>
-          </a:solidFill>
-          <a:ln w="9525">
-            <a:solidFill>
-              <a:srgbClr val="E2E8F0"/>
-            </a:solidFill>
-            <a:prstDash val="solid"/>
-          </a:ln>
-          <a:effectLst>
-            <a:outerShdw blurRad="101600" dist="25400" dir="5400000" algn="bl" rotWithShape="0">
-              <a:srgbClr val="1B2A4A">
-                <a:alpha val="10000"/>
-              </a:srgbClr>
-            </a:outerShdw>
-          </a:effectLst>
-        </p:spPr>
-      </p:sp>
-      <p:sp>
-        <p:nvSpPr>
-          <p:cNvPr id="5" name="Text 3"/>
-          <p:cNvSpPr txBox="1"/>
-          <p:nvPr/>
-        </p:nvSpPr>
-        <p:spPr>
-          <a:xfrm>
-            <a:off x="822960" y="1965960"/>
-            <a:ext cx="2018538" cy="274320"/>
-          </a:xfrm>
-          <a:prstGeom prst="rect">
-            <a:avLst/>
-          </a:prstGeom>
-          <a:noFill/>
-          <a:ln/>
-        </p:spPr>
-        <p:txBody>
-          <a:bodyPr wrap="square" lIns="0" tIns="0" rIns="0" bIns="0" rtlCol="0" anchor="ctr"/>
-          <a:lstStyle/>
-          <a:p>
-            <a:pPr marL="0" indent="0">
-              <a:buNone/>
-            </a:pPr>
-            <a:r>
-              <a:rPr lang="en-US" sz="1200" b="1" kern="0" spc="200" dirty="0">
-                <a:solidFill>
-                  <a:schemeClr val="accent6"/>
-                </a:solidFill>
-              </a:rPr>
-              <a:t>TOTAL ORDERS</a:t>
-            </a:r>
-            <a:endParaRPr lang="en-US" sz="1200" dirty="0"/>
-          </a:p>
-        </p:txBody>
-      </p:sp>
-      <p:sp>
-        <p:nvSpPr>
-          <p:cNvPr id="6" name="Text 4"/>
-          <p:cNvSpPr txBox="1"/>
-          <p:nvPr/>
-        </p:nvSpPr>
-        <p:spPr>
-          <a:xfrm>
-            <a:off x="822960" y="2377440"/>
-            <a:ext cx="2018538" cy="822960"/>
-          </a:xfrm>
-          <a:prstGeom prst="rect">
-            <a:avLst/>
-          </a:prstGeom>
-          <a:noFill/>
-          <a:ln/>
-        </p:spPr>
-        <p:txBody>
-          <a:bodyPr wrap="square" lIns="0" tIns="0" rIns="0" bIns="0" rtlCol="0" anchor="ctr"/>
-          <a:lstStyle/>
-          <a:p>
-            <a:pPr marL="0" indent="0">
-              <a:buNone/>
-            </a:pPr>
-            <a:r>
-              <a:rPr lang="en-US" sz="3800" b="1" dirty="0">
-                <a:solidFill>
-                  <a:schemeClr val="tx1"/>
-                </a:solidFill>
-                <a:latin typeface="Arial" pitchFamily="34" charset="0"/>
-                <a:ea typeface="Arial" pitchFamily="34" charset="-122"/>
-                <a:cs typeface="Arial" pitchFamily="34" charset="-120"/>
-              </a:rPr>
-              <a:t>25,035</a:t>
-            </a:r>
-            <a:endParaRPr lang="en-US" sz="3800" dirty="0"/>
-          </a:p>
-        </p:txBody>
-      </p:sp>
-      <p:sp>
-        <p:nvSpPr>
-          <p:cNvPr id="7" name="Text 5"/>
-          <p:cNvSpPr txBox="1"/>
-          <p:nvPr/>
-        </p:nvSpPr>
-        <p:spPr>
-          <a:xfrm>
-            <a:off x="822960" y="3246120"/>
-            <a:ext cx="2018538" cy="320040"/>
-          </a:xfrm>
-          <a:prstGeom prst="rect">
-            <a:avLst/>
-          </a:prstGeom>
-          <a:noFill/>
-          <a:ln/>
-        </p:spPr>
-        <p:txBody>
-          <a:bodyPr wrap="square" lIns="0" tIns="0" rIns="0" bIns="0" rtlCol="0" anchor="ctr"/>
-          <a:lstStyle/>
-          <a:p>
-            <a:pPr marL="0" indent="0">
-              <a:buNone/>
-            </a:pPr>
-            <a:r>
-              <a:rPr lang="en-US" sz="1400" dirty="0">
-                <a:solidFill>
-                  <a:schemeClr val="tx2"/>
-                </a:solidFill>
-              </a:rPr>
-              <a:t>Across all regions &amp; segments</a:t>
-            </a:r>
-            <a:endParaRPr lang="en-US" sz="1400" dirty="0"/>
-          </a:p>
-        </p:txBody>
-      </p:sp>
-      <p:sp>
-        <p:nvSpPr>
-          <p:cNvPr id="8" name="KPI ACTIVE CUSTOMERS"/>
-          <p:cNvSpPr/>
-          <p:nvPr/>
-        </p:nvSpPr>
-        <p:spPr>
-          <a:xfrm>
-            <a:off x="3390138" y="1691640"/>
-            <a:ext cx="2567178" cy="2148840"/>
-          </a:xfrm>
-          <a:prstGeom prst="roundRect">
-            <a:avLst>
-              <a:gd name="adj" fmla="val 4255"/>
-            </a:avLst>
-          </a:prstGeom>
-          <a:solidFill>
-            <a:schemeClr val="bg2"/>
-          </a:solidFill>
-          <a:ln w="9525">
-            <a:solidFill>
-              <a:srgbClr val="E2E8F0"/>
-            </a:solidFill>
-            <a:prstDash val="solid"/>
-          </a:ln>
-          <a:effectLst>
-            <a:outerShdw blurRad="101600" dist="25400" dir="5400000" algn="bl" rotWithShape="0">
-              <a:srgbClr val="1B2A4A">
-                <a:alpha val="10000"/>
-              </a:srgbClr>
-            </a:outerShdw>
-          </a:effectLst>
-        </p:spPr>
-      </p:sp>
-      <p:sp>
-        <p:nvSpPr>
-          <p:cNvPr id="9" name="Text 7"/>
-          <p:cNvSpPr txBox="1"/>
-          <p:nvPr/>
-        </p:nvSpPr>
-        <p:spPr>
-          <a:xfrm>
-            <a:off x="3664458" y="1965960"/>
-            <a:ext cx="2018538" cy="274320"/>
-          </a:xfrm>
-          <a:prstGeom prst="rect">
-            <a:avLst/>
-          </a:prstGeom>
-          <a:noFill/>
-          <a:ln/>
-        </p:spPr>
-        <p:txBody>
-          <a:bodyPr wrap="square" lIns="0" tIns="0" rIns="0" bIns="0" rtlCol="0" anchor="ctr"/>
-          <a:lstStyle/>
-          <a:p>
-            <a:pPr marL="0" indent="0">
-              <a:buNone/>
-            </a:pPr>
-            <a:r>
-              <a:rPr lang="en-US" sz="1200" b="1" kern="0" spc="200" dirty="0">
-                <a:solidFill>
-                  <a:schemeClr val="accent6"/>
-                </a:solidFill>
-              </a:rPr>
-              <a:t>ACTIVE CUSTOMERS</a:t>
-            </a:r>
-            <a:endParaRPr lang="en-US" sz="1200" dirty="0"/>
-          </a:p>
-        </p:txBody>
-      </p:sp>
-      <p:sp>
-        <p:nvSpPr>
-          <p:cNvPr id="10" name="Text 8"/>
-          <p:cNvSpPr txBox="1"/>
-          <p:nvPr/>
-        </p:nvSpPr>
-        <p:spPr>
-          <a:xfrm>
-            <a:off x="3664458" y="2377440"/>
-            <a:ext cx="2018538" cy="822960"/>
-          </a:xfrm>
-          <a:prstGeom prst="rect">
-            <a:avLst/>
-          </a:prstGeom>
-          <a:noFill/>
-          <a:ln/>
-        </p:spPr>
-        <p:txBody>
-          <a:bodyPr wrap="square" lIns="0" tIns="0" rIns="0" bIns="0" rtlCol="0" anchor="ctr"/>
-          <a:lstStyle/>
-          <a:p>
-            <a:pPr marL="0" indent="0">
-              <a:buNone/>
-            </a:pPr>
-            <a:r>
-              <a:rPr lang="en-US" sz="3800" b="1" dirty="0">
-                <a:solidFill>
-                  <a:schemeClr val="tx1"/>
-                </a:solidFill>
-                <a:latin typeface="Arial" pitchFamily="34" charset="0"/>
-                <a:ea typeface="Arial" pitchFamily="34" charset="-122"/>
-                <a:cs typeface="Arial" pitchFamily="34" charset="-120"/>
-              </a:rPr>
-              <a:t>1,589</a:t>
-            </a:r>
-            <a:endParaRPr lang="en-US" sz="3800" dirty="0"/>
-          </a:p>
-        </p:txBody>
-      </p:sp>
-      <p:sp>
-        <p:nvSpPr>
-          <p:cNvPr id="11" name="Text 9"/>
-          <p:cNvSpPr txBox="1"/>
-          <p:nvPr/>
-        </p:nvSpPr>
-        <p:spPr>
-          <a:xfrm>
-            <a:off x="3664458" y="3246120"/>
-            <a:ext cx="2018538" cy="320040"/>
-          </a:xfrm>
-          <a:prstGeom prst="rect">
-            <a:avLst/>
-          </a:prstGeom>
-          <a:noFill/>
-          <a:ln/>
-        </p:spPr>
-        <p:txBody>
-          <a:bodyPr wrap="square" lIns="0" tIns="0" rIns="0" bIns="0" rtlCol="0" anchor="ctr"/>
-          <a:lstStyle/>
-          <a:p>
-            <a:pPr marL="0" indent="0">
-              <a:buNone/>
-            </a:pPr>
-            <a:r>
-              <a:rPr lang="en-US" sz="1400" dirty="0">
-                <a:solidFill>
-                  <a:schemeClr val="tx2"/>
-                </a:solidFill>
-              </a:rPr>
-              <a:t>178,312 units sold</a:t>
-            </a:r>
-            <a:endParaRPr lang="en-US" sz="1400" dirty="0"/>
-          </a:p>
-        </p:txBody>
-      </p:sp>
-      <p:sp>
-        <p:nvSpPr>
-          <p:cNvPr id="12" name="KPI GROSS REVENUE"/>
-          <p:cNvSpPr/>
-          <p:nvPr/>
-        </p:nvSpPr>
-        <p:spPr>
-          <a:xfrm>
-            <a:off x="6231636" y="1691640"/>
-            <a:ext cx="2567178" cy="2148840"/>
-          </a:xfrm>
-          <a:prstGeom prst="roundRect">
-            <a:avLst>
-              <a:gd name="adj" fmla="val 4255"/>
-            </a:avLst>
-          </a:prstGeom>
-          <a:solidFill>
-            <a:schemeClr val="bg2"/>
-          </a:solidFill>
-          <a:ln w="9525">
-            <a:solidFill>
-              <a:srgbClr val="E2E8F0"/>
-            </a:solidFill>
-            <a:prstDash val="solid"/>
-          </a:ln>
-          <a:effectLst>
-            <a:outerShdw blurRad="101600" dist="25400" dir="5400000" algn="bl" rotWithShape="0">
-              <a:srgbClr val="1B2A4A">
-                <a:alpha val="10000"/>
-              </a:srgbClr>
-            </a:outerShdw>
-          </a:effectLst>
-        </p:spPr>
-      </p:sp>
-      <p:sp>
-        <p:nvSpPr>
-          <p:cNvPr id="13" name="Text 11"/>
-          <p:cNvSpPr txBox="1"/>
-          <p:nvPr/>
-        </p:nvSpPr>
-        <p:spPr>
-          <a:xfrm>
-            <a:off x="6505956" y="1965960"/>
-            <a:ext cx="2018538" cy="274320"/>
-          </a:xfrm>
-          <a:prstGeom prst="rect">
-            <a:avLst/>
-          </a:prstGeom>
-          <a:noFill/>
-          <a:ln/>
-        </p:spPr>
-        <p:txBody>
-          <a:bodyPr wrap="square" lIns="0" tIns="0" rIns="0" bIns="0" rtlCol="0" anchor="ctr"/>
-          <a:lstStyle/>
-          <a:p>
-            <a:pPr marL="0" indent="0">
-              <a:buNone/>
-            </a:pPr>
-            <a:r>
-              <a:rPr lang="en-US" sz="1200" b="1" kern="0" spc="200" dirty="0">
-                <a:solidFill>
-                  <a:schemeClr val="accent6"/>
-                </a:solidFill>
-              </a:rPr>
-              <a:t>GROSS REVENUE</a:t>
-            </a:r>
-            <a:endParaRPr lang="en-US" sz="1200" dirty="0"/>
-          </a:p>
-        </p:txBody>
-      </p:sp>
-      <p:sp>
-        <p:nvSpPr>
-          <p:cNvPr id="14" name="Text 12"/>
-          <p:cNvSpPr txBox="1"/>
-          <p:nvPr/>
-        </p:nvSpPr>
-        <p:spPr>
-          <a:xfrm>
-            <a:off x="6505956" y="2377440"/>
-            <a:ext cx="2018538" cy="822960"/>
-          </a:xfrm>
-          <a:prstGeom prst="rect">
-            <a:avLst/>
-          </a:prstGeom>
-          <a:noFill/>
-          <a:ln/>
-        </p:spPr>
-        <p:txBody>
-          <a:bodyPr wrap="square" lIns="0" tIns="0" rIns="0" bIns="0" rtlCol="0" anchor="ctr"/>
-          <a:lstStyle/>
-          <a:p>
-            <a:pPr marL="0" indent="0">
-              <a:buNone/>
-            </a:pPr>
-            <a:r>
-              <a:rPr lang="en-US" sz="3800" b="1" dirty="0">
-                <a:solidFill>
-                  <a:schemeClr val="tx1"/>
-                </a:solidFill>
-                <a:latin typeface="Arial" pitchFamily="34" charset="0"/>
-                <a:ea typeface="Arial" pitchFamily="34" charset="-122"/>
-                <a:cs typeface="Arial" pitchFamily="34" charset="-120"/>
-              </a:rPr>
-              <a:t>$12.64M</a:t>
-            </a:r>
-            <a:endParaRPr lang="en-US" sz="3800" dirty="0"/>
-          </a:p>
-        </p:txBody>
-      </p:sp>
-      <p:sp>
-        <p:nvSpPr>
-          <p:cNvPr id="15" name="Text 13"/>
-          <p:cNvSpPr txBox="1"/>
-          <p:nvPr/>
-        </p:nvSpPr>
-        <p:spPr>
-          <a:xfrm>
-            <a:off x="6505956" y="3246120"/>
-            <a:ext cx="2018538" cy="320040"/>
-          </a:xfrm>
-          <a:prstGeom prst="rect">
-            <a:avLst/>
-          </a:prstGeom>
-          <a:noFill/>
-          <a:ln/>
-        </p:spPr>
-        <p:txBody>
-          <a:bodyPr wrap="square" lIns="0" tIns="0" rIns="0" bIns="0" rtlCol="0" anchor="ctr"/>
-          <a:lstStyle/>
-          <a:p>
-            <a:pPr marL="0" indent="0">
-              <a:buNone/>
-            </a:pPr>
-            <a:r>
-              <a:rPr lang="en-US" sz="1400" dirty="0">
-                <a:solidFill>
-                  <a:schemeClr val="tx2"/>
-                </a:solidFill>
-              </a:rPr>
-              <a:t>Total sales, all categories</a:t>
-            </a:r>
-            <a:endParaRPr lang="en-US" sz="1400" dirty="0"/>
-          </a:p>
-        </p:txBody>
-      </p:sp>
-      <p:sp>
-        <p:nvSpPr>
-          <p:cNvPr id="16" name="KPI NET PROFIT"/>
-          <p:cNvSpPr/>
-          <p:nvPr/>
-        </p:nvSpPr>
-        <p:spPr>
-          <a:xfrm>
-            <a:off x="9073134" y="1691640"/>
-            <a:ext cx="2567178" cy="2148840"/>
-          </a:xfrm>
-          <a:prstGeom prst="roundRect">
-            <a:avLst>
-              <a:gd name="adj" fmla="val 4255"/>
-            </a:avLst>
-          </a:prstGeom>
-          <a:solidFill>
-            <a:schemeClr val="accent1"/>
-          </a:solidFill>
-          <a:ln w="9525">
-            <a:solidFill>
-              <a:srgbClr val="E2E8F0"/>
-            </a:solidFill>
-            <a:prstDash val="solid"/>
-          </a:ln>
-          <a:effectLst>
-            <a:outerShdw blurRad="101600" dist="25400" dir="5400000" algn="bl" rotWithShape="0">
-              <a:srgbClr val="1B2A4A">
-                <a:alpha val="10000"/>
-              </a:srgbClr>
-            </a:outerShdw>
-          </a:effectLst>
-        </p:spPr>
-      </p:sp>
-      <p:sp>
-        <p:nvSpPr>
-          <p:cNvPr id="17" name="Text 15"/>
-          <p:cNvSpPr txBox="1"/>
-          <p:nvPr/>
-        </p:nvSpPr>
-        <p:spPr>
-          <a:xfrm>
-            <a:off x="9347454" y="1965960"/>
-            <a:ext cx="2018538" cy="274320"/>
-          </a:xfrm>
-          <a:prstGeom prst="rect">
-            <a:avLst/>
-          </a:prstGeom>
-          <a:noFill/>
-          <a:ln/>
-        </p:spPr>
-        <p:txBody>
-          <a:bodyPr wrap="square" lIns="0" tIns="0" rIns="0" bIns="0" rtlCol="0" anchor="ctr"/>
-          <a:lstStyle/>
-          <a:p>
-            <a:pPr marL="0" indent="0">
-              <a:buNone/>
-            </a:pPr>
-            <a:r>
-              <a:rPr lang="en-US" sz="1200" b="1" kern="0" spc="200" dirty="0">
-                <a:solidFill>
-                  <a:schemeClr val="bg2"/>
-                </a:solidFill>
-              </a:rPr>
-              <a:t>NET PROFIT</a:t>
-            </a:r>
-            <a:endParaRPr lang="en-US" sz="1200" dirty="0"/>
-          </a:p>
-        </p:txBody>
-      </p:sp>
-      <p:sp>
-        <p:nvSpPr>
-          <p:cNvPr id="18" name="Text 16"/>
-          <p:cNvSpPr txBox="1"/>
-          <p:nvPr/>
-        </p:nvSpPr>
-        <p:spPr>
-          <a:xfrm>
-            <a:off x="9347454" y="2377440"/>
-            <a:ext cx="2018538" cy="822960"/>
-          </a:xfrm>
-          <a:prstGeom prst="rect">
-            <a:avLst/>
-          </a:prstGeom>
-          <a:noFill/>
-          <a:ln/>
-        </p:spPr>
-        <p:txBody>
-          <a:bodyPr wrap="square" lIns="0" tIns="0" rIns="0" bIns="0" rtlCol="0" anchor="ctr"/>
-          <a:lstStyle/>
-          <a:p>
-            <a:pPr marL="0" indent="0">
-              <a:buNone/>
-            </a:pPr>
-            <a:r>
-              <a:rPr lang="en-US" sz="3800" b="1" dirty="0">
-                <a:solidFill>
-                  <a:schemeClr val="bg2"/>
-                </a:solidFill>
-                <a:latin typeface="Arial" pitchFamily="34" charset="0"/>
-                <a:ea typeface="Arial" pitchFamily="34" charset="-122"/>
-                <a:cs typeface="Arial" pitchFamily="34" charset="-120"/>
-              </a:rPr>
-              <a:t>$1.47M</a:t>
-            </a:r>
-            <a:endParaRPr lang="en-US" sz="3800" dirty="0"/>
-          </a:p>
-        </p:txBody>
-      </p:sp>
-      <p:sp>
-        <p:nvSpPr>
-          <p:cNvPr id="19" name="Text 17"/>
-          <p:cNvSpPr txBox="1"/>
-          <p:nvPr/>
-        </p:nvSpPr>
-        <p:spPr>
-          <a:xfrm>
-            <a:off x="9347454" y="3246120"/>
-            <a:ext cx="2018538" cy="320040"/>
-          </a:xfrm>
-          <a:prstGeom prst="rect">
-            <a:avLst/>
-          </a:prstGeom>
-          <a:noFill/>
-          <a:ln/>
-        </p:spPr>
-        <p:txBody>
-          <a:bodyPr wrap="square" lIns="0" tIns="0" rIns="0" bIns="0" rtlCol="0" anchor="ctr"/>
-          <a:lstStyle/>
-          <a:p>
-            <a:pPr marL="0" indent="0">
-              <a:buNone/>
-            </a:pPr>
-            <a:r>
-              <a:rPr lang="en-US" sz="1400" dirty="0">
-                <a:solidFill>
-                  <a:schemeClr val="bg2"/>
-                </a:solidFill>
-              </a:rPr>
-              <a:t>After product costs</a:t>
-            </a:r>
-            <a:endParaRPr lang="en-US" sz="1400" dirty="0"/>
-          </a:p>
-        </p:txBody>
-      </p:sp>
       <p:grpSp>
         <p:nvGrpSpPr>
-          <p:cNvPr id="33" name="Group 32">
+          <p:cNvPr id="35" name="Group 34">
             <a:extLst>
               <a:ext uri="{FF2B5EF4-FFF2-40B4-BE49-F238E27FC236}">
-                <a16:creationId xmlns:a16="http://schemas.microsoft.com/office/drawing/2014/main" id="{52158D1B-0654-411D-BD14-82865865F9F2}"/>
+                <a16:creationId xmlns:a16="http://schemas.microsoft.com/office/drawing/2014/main" id="{511CD47B-0A96-4F9E-9462-9E3CBB464463}"/>
               </a:ext>
             </a:extLst>
           </p:cNvPr>
@@ -2334,8 +2168,630 @@
         </p:nvGrpSpPr>
         <p:grpSpPr>
           <a:xfrm>
-            <a:off x="3390138" y="4160520"/>
-            <a:ext cx="5408676" cy="2240280"/>
+            <a:off x="1435205" y="1600200"/>
+            <a:ext cx="8250174" cy="2148840"/>
+            <a:chOff x="548640" y="1691640"/>
+            <a:chExt cx="8250174" cy="2148840"/>
+          </a:xfrm>
+        </p:grpSpPr>
+        <p:sp>
+          <p:nvSpPr>
+            <p:cNvPr id="4" name="KPI TOTAL ORDERS"/>
+            <p:cNvSpPr/>
+            <p:nvPr/>
+          </p:nvSpPr>
+          <p:spPr>
+            <a:xfrm>
+              <a:off x="548640" y="1691640"/>
+              <a:ext cx="2567178" cy="2148840"/>
+            </a:xfrm>
+            <a:prstGeom prst="roundRect">
+              <a:avLst>
+                <a:gd name="adj" fmla="val 4255"/>
+              </a:avLst>
+            </a:prstGeom>
+            <a:solidFill>
+              <a:schemeClr val="bg2"/>
+            </a:solidFill>
+            <a:ln w="9525">
+              <a:solidFill>
+                <a:srgbClr val="E2E8F0"/>
+              </a:solidFill>
+              <a:prstDash val="solid"/>
+            </a:ln>
+            <a:effectLst>
+              <a:outerShdw blurRad="101600" dist="25400" dir="5400000" algn="bl" rotWithShape="0">
+                <a:srgbClr val="1B2A4A">
+                  <a:alpha val="10000"/>
+                </a:srgbClr>
+              </a:outerShdw>
+            </a:effectLst>
+          </p:spPr>
+        </p:sp>
+        <p:sp>
+          <p:nvSpPr>
+            <p:cNvPr id="5" name="Text 3"/>
+            <p:cNvSpPr txBox="1"/>
+            <p:nvPr/>
+          </p:nvSpPr>
+          <p:spPr>
+            <a:xfrm>
+              <a:off x="822960" y="1965960"/>
+              <a:ext cx="2018538" cy="274320"/>
+            </a:xfrm>
+            <a:prstGeom prst="rect">
+              <a:avLst/>
+            </a:prstGeom>
+            <a:noFill/>
+            <a:ln/>
+          </p:spPr>
+          <p:txBody>
+            <a:bodyPr wrap="square" lIns="0" tIns="0" rIns="0" bIns="0" rtlCol="0" anchor="ctr"/>
+            <a:lstStyle/>
+            <a:p>
+              <a:pPr marL="0" indent="0">
+                <a:buNone/>
+              </a:pPr>
+              <a:r>
+                <a:rPr lang="en-US" sz="1200" b="1" kern="0" spc="200" dirty="0">
+                  <a:solidFill>
+                    <a:schemeClr val="accent6"/>
+                  </a:solidFill>
+                </a:rPr>
+                <a:t>TOTAL ORDERS</a:t>
+              </a:r>
+              <a:endParaRPr lang="en-US" sz="1200" dirty="0"/>
+            </a:p>
+          </p:txBody>
+        </p:sp>
+        <p:sp>
+          <p:nvSpPr>
+            <p:cNvPr id="6" name="Text 4"/>
+            <p:cNvSpPr txBox="1"/>
+            <p:nvPr/>
+          </p:nvSpPr>
+          <p:spPr>
+            <a:xfrm>
+              <a:off x="822960" y="2377440"/>
+              <a:ext cx="2018538" cy="822960"/>
+            </a:xfrm>
+            <a:prstGeom prst="rect">
+              <a:avLst/>
+            </a:prstGeom>
+            <a:noFill/>
+            <a:ln/>
+          </p:spPr>
+          <p:txBody>
+            <a:bodyPr wrap="square" lIns="0" tIns="0" rIns="0" bIns="0" rtlCol="0" anchor="ctr"/>
+            <a:lstStyle/>
+            <a:p>
+              <a:pPr marL="0" indent="0">
+                <a:buNone/>
+              </a:pPr>
+              <a:r>
+                <a:rPr lang="en-US" sz="3800" b="1" dirty="0">
+                  <a:solidFill>
+                    <a:schemeClr val="tx1"/>
+                  </a:solidFill>
+                  <a:latin typeface="Arial" pitchFamily="34" charset="0"/>
+                  <a:ea typeface="Arial" pitchFamily="34" charset="-122"/>
+                  <a:cs typeface="Arial" pitchFamily="34" charset="-120"/>
+                </a:rPr>
+                <a:t>25,035</a:t>
+              </a:r>
+              <a:endParaRPr lang="en-US" sz="3800" dirty="0"/>
+            </a:p>
+          </p:txBody>
+        </p:sp>
+        <p:sp>
+          <p:nvSpPr>
+            <p:cNvPr id="7" name="Text 5"/>
+            <p:cNvSpPr txBox="1"/>
+            <p:nvPr/>
+          </p:nvSpPr>
+          <p:spPr>
+            <a:xfrm>
+              <a:off x="822960" y="3246120"/>
+              <a:ext cx="2018538" cy="320040"/>
+            </a:xfrm>
+            <a:prstGeom prst="rect">
+              <a:avLst/>
+            </a:prstGeom>
+            <a:noFill/>
+            <a:ln/>
+          </p:spPr>
+          <p:txBody>
+            <a:bodyPr wrap="square" lIns="0" tIns="0" rIns="0" bIns="0" rtlCol="0" anchor="ctr"/>
+            <a:lstStyle/>
+            <a:p>
+              <a:pPr marL="0" indent="0">
+                <a:buNone/>
+              </a:pPr>
+              <a:r>
+                <a:rPr lang="en-US" sz="1400" dirty="0">
+                  <a:solidFill>
+                    <a:schemeClr val="tx2"/>
+                  </a:solidFill>
+                </a:rPr>
+                <a:t>Across all regions &amp; segments</a:t>
+              </a:r>
+              <a:endParaRPr lang="en-US" sz="1400" dirty="0"/>
+            </a:p>
+          </p:txBody>
+        </p:sp>
+        <p:sp>
+          <p:nvSpPr>
+            <p:cNvPr id="8" name="KPI ACTIVE CUSTOMERS"/>
+            <p:cNvSpPr/>
+            <p:nvPr/>
+          </p:nvSpPr>
+          <p:spPr>
+            <a:xfrm>
+              <a:off x="3390138" y="1691640"/>
+              <a:ext cx="2567178" cy="2148840"/>
+            </a:xfrm>
+            <a:prstGeom prst="roundRect">
+              <a:avLst>
+                <a:gd name="adj" fmla="val 4255"/>
+              </a:avLst>
+            </a:prstGeom>
+            <a:solidFill>
+              <a:schemeClr val="bg2"/>
+            </a:solidFill>
+            <a:ln w="9525">
+              <a:solidFill>
+                <a:srgbClr val="E2E8F0"/>
+              </a:solidFill>
+              <a:prstDash val="solid"/>
+            </a:ln>
+            <a:effectLst>
+              <a:outerShdw blurRad="101600" dist="25400" dir="5400000" algn="bl" rotWithShape="0">
+                <a:srgbClr val="1B2A4A">
+                  <a:alpha val="10000"/>
+                </a:srgbClr>
+              </a:outerShdw>
+            </a:effectLst>
+          </p:spPr>
+        </p:sp>
+        <p:sp>
+          <p:nvSpPr>
+            <p:cNvPr id="9" name="Text 7"/>
+            <p:cNvSpPr txBox="1"/>
+            <p:nvPr/>
+          </p:nvSpPr>
+          <p:spPr>
+            <a:xfrm>
+              <a:off x="3664458" y="1965960"/>
+              <a:ext cx="2018538" cy="274320"/>
+            </a:xfrm>
+            <a:prstGeom prst="rect">
+              <a:avLst/>
+            </a:prstGeom>
+            <a:noFill/>
+            <a:ln/>
+          </p:spPr>
+          <p:txBody>
+            <a:bodyPr wrap="square" lIns="0" tIns="0" rIns="0" bIns="0" rtlCol="0" anchor="ctr"/>
+            <a:lstStyle/>
+            <a:p>
+              <a:pPr marL="0" indent="0">
+                <a:buNone/>
+              </a:pPr>
+              <a:r>
+                <a:rPr lang="en-US" sz="1200" b="1" kern="0" spc="200" dirty="0">
+                  <a:solidFill>
+                    <a:schemeClr val="accent6"/>
+                  </a:solidFill>
+                </a:rPr>
+                <a:t>ACTIVE CUSTOMERS</a:t>
+              </a:r>
+              <a:endParaRPr lang="en-US" sz="1200" dirty="0"/>
+            </a:p>
+          </p:txBody>
+        </p:sp>
+        <p:sp>
+          <p:nvSpPr>
+            <p:cNvPr id="10" name="Text 8"/>
+            <p:cNvSpPr txBox="1"/>
+            <p:nvPr/>
+          </p:nvSpPr>
+          <p:spPr>
+            <a:xfrm>
+              <a:off x="3664458" y="2377440"/>
+              <a:ext cx="2018538" cy="822960"/>
+            </a:xfrm>
+            <a:prstGeom prst="rect">
+              <a:avLst/>
+            </a:prstGeom>
+            <a:noFill/>
+            <a:ln/>
+          </p:spPr>
+          <p:txBody>
+            <a:bodyPr wrap="square" lIns="0" tIns="0" rIns="0" bIns="0" rtlCol="0" anchor="ctr"/>
+            <a:lstStyle/>
+            <a:p>
+              <a:pPr marL="0" indent="0">
+                <a:buNone/>
+              </a:pPr>
+              <a:r>
+                <a:rPr lang="en-US" sz="3800" b="1" dirty="0">
+                  <a:solidFill>
+                    <a:schemeClr val="tx1"/>
+                  </a:solidFill>
+                  <a:latin typeface="Arial" pitchFamily="34" charset="0"/>
+                  <a:ea typeface="Arial" pitchFamily="34" charset="-122"/>
+                  <a:cs typeface="Arial" pitchFamily="34" charset="-120"/>
+                </a:rPr>
+                <a:t>1,589</a:t>
+              </a:r>
+              <a:endParaRPr lang="en-US" sz="3800" dirty="0"/>
+            </a:p>
+          </p:txBody>
+        </p:sp>
+        <p:sp>
+          <p:nvSpPr>
+            <p:cNvPr id="11" name="Text 9"/>
+            <p:cNvSpPr txBox="1"/>
+            <p:nvPr/>
+          </p:nvSpPr>
+          <p:spPr>
+            <a:xfrm>
+              <a:off x="3664458" y="3246120"/>
+              <a:ext cx="2018538" cy="320040"/>
+            </a:xfrm>
+            <a:prstGeom prst="rect">
+              <a:avLst/>
+            </a:prstGeom>
+            <a:noFill/>
+            <a:ln/>
+          </p:spPr>
+          <p:txBody>
+            <a:bodyPr wrap="square" lIns="0" tIns="0" rIns="0" bIns="0" rtlCol="0" anchor="ctr"/>
+            <a:lstStyle/>
+            <a:p>
+              <a:pPr marL="0" indent="0">
+                <a:buNone/>
+              </a:pPr>
+              <a:r>
+                <a:rPr lang="en-US" sz="1400" dirty="0">
+                  <a:solidFill>
+                    <a:schemeClr val="tx2"/>
+                  </a:solidFill>
+                </a:rPr>
+                <a:t>178,312 units sold</a:t>
+              </a:r>
+              <a:endParaRPr lang="en-US" sz="1400" dirty="0"/>
+            </a:p>
+          </p:txBody>
+        </p:sp>
+        <p:sp>
+          <p:nvSpPr>
+            <p:cNvPr id="12" name="KPI GROSS REVENUE"/>
+            <p:cNvSpPr/>
+            <p:nvPr/>
+          </p:nvSpPr>
+          <p:spPr>
+            <a:xfrm>
+              <a:off x="6231636" y="1691640"/>
+              <a:ext cx="2567178" cy="2148840"/>
+            </a:xfrm>
+            <a:prstGeom prst="roundRect">
+              <a:avLst>
+                <a:gd name="adj" fmla="val 4255"/>
+              </a:avLst>
+            </a:prstGeom>
+            <a:solidFill>
+              <a:schemeClr val="bg2"/>
+            </a:solidFill>
+            <a:ln w="9525">
+              <a:solidFill>
+                <a:srgbClr val="E2E8F0"/>
+              </a:solidFill>
+              <a:prstDash val="solid"/>
+            </a:ln>
+            <a:effectLst>
+              <a:outerShdw blurRad="101600" dist="25400" dir="5400000" algn="bl" rotWithShape="0">
+                <a:srgbClr val="1B2A4A">
+                  <a:alpha val="10000"/>
+                </a:srgbClr>
+              </a:outerShdw>
+            </a:effectLst>
+          </p:spPr>
+        </p:sp>
+        <p:sp>
+          <p:nvSpPr>
+            <p:cNvPr id="13" name="Text 11"/>
+            <p:cNvSpPr txBox="1"/>
+            <p:nvPr/>
+          </p:nvSpPr>
+          <p:spPr>
+            <a:xfrm>
+              <a:off x="6505956" y="1965960"/>
+              <a:ext cx="2018538" cy="274320"/>
+            </a:xfrm>
+            <a:prstGeom prst="rect">
+              <a:avLst/>
+            </a:prstGeom>
+            <a:noFill/>
+            <a:ln/>
+          </p:spPr>
+          <p:txBody>
+            <a:bodyPr wrap="square" lIns="0" tIns="0" rIns="0" bIns="0" rtlCol="0" anchor="ctr"/>
+            <a:lstStyle/>
+            <a:p>
+              <a:pPr marL="0" indent="0">
+                <a:buNone/>
+              </a:pPr>
+              <a:r>
+                <a:rPr lang="en-US" sz="1200" b="1" kern="0" spc="200" dirty="0">
+                  <a:solidFill>
+                    <a:schemeClr val="accent6"/>
+                  </a:solidFill>
+                </a:rPr>
+                <a:t>GROSS REVENUE</a:t>
+              </a:r>
+              <a:endParaRPr lang="en-US" sz="1200" dirty="0"/>
+            </a:p>
+          </p:txBody>
+        </p:sp>
+        <p:sp>
+          <p:nvSpPr>
+            <p:cNvPr id="14" name="Text 12"/>
+            <p:cNvSpPr txBox="1"/>
+            <p:nvPr/>
+          </p:nvSpPr>
+          <p:spPr>
+            <a:xfrm>
+              <a:off x="6505956" y="2377440"/>
+              <a:ext cx="2018538" cy="822960"/>
+            </a:xfrm>
+            <a:prstGeom prst="rect">
+              <a:avLst/>
+            </a:prstGeom>
+            <a:noFill/>
+            <a:ln/>
+          </p:spPr>
+          <p:txBody>
+            <a:bodyPr wrap="square" lIns="0" tIns="0" rIns="0" bIns="0" rtlCol="0" anchor="ctr"/>
+            <a:lstStyle/>
+            <a:p>
+              <a:pPr marL="0" indent="0">
+                <a:buNone/>
+              </a:pPr>
+              <a:r>
+                <a:rPr lang="en-US" sz="3800" b="1" dirty="0">
+                  <a:solidFill>
+                    <a:schemeClr val="tx1"/>
+                  </a:solidFill>
+                  <a:latin typeface="Arial" pitchFamily="34" charset="0"/>
+                  <a:ea typeface="Arial" pitchFamily="34" charset="-122"/>
+                  <a:cs typeface="Arial" pitchFamily="34" charset="-120"/>
+                </a:rPr>
+                <a:t>$12.64M</a:t>
+              </a:r>
+              <a:endParaRPr lang="en-US" sz="3800" dirty="0"/>
+            </a:p>
+          </p:txBody>
+        </p:sp>
+        <p:sp>
+          <p:nvSpPr>
+            <p:cNvPr id="15" name="Text 13"/>
+            <p:cNvSpPr txBox="1"/>
+            <p:nvPr/>
+          </p:nvSpPr>
+          <p:spPr>
+            <a:xfrm>
+              <a:off x="6505956" y="3246120"/>
+              <a:ext cx="2018538" cy="320040"/>
+            </a:xfrm>
+            <a:prstGeom prst="rect">
+              <a:avLst/>
+            </a:prstGeom>
+            <a:noFill/>
+            <a:ln/>
+          </p:spPr>
+          <p:txBody>
+            <a:bodyPr wrap="square" lIns="0" tIns="0" rIns="0" bIns="0" rtlCol="0" anchor="ctr"/>
+            <a:lstStyle/>
+            <a:p>
+              <a:pPr marL="0" indent="0">
+                <a:buNone/>
+              </a:pPr>
+              <a:r>
+                <a:rPr lang="en-US" sz="1400" dirty="0">
+                  <a:solidFill>
+                    <a:schemeClr val="tx2"/>
+                  </a:solidFill>
+                </a:rPr>
+                <a:t>Total sales, all categories</a:t>
+              </a:r>
+              <a:endParaRPr lang="en-US" sz="1400" dirty="0"/>
+            </a:p>
+          </p:txBody>
+        </p:sp>
+      </p:grpSp>
+      <p:grpSp>
+        <p:nvGrpSpPr>
+          <p:cNvPr id="34" name="Group 33">
+            <a:extLst>
+              <a:ext uri="{FF2B5EF4-FFF2-40B4-BE49-F238E27FC236}">
+                <a16:creationId xmlns:a16="http://schemas.microsoft.com/office/drawing/2014/main" id="{96BCA027-A4E9-40A0-95E8-0A9A76AB2294}"/>
+              </a:ext>
+            </a:extLst>
+          </p:cNvPr>
+          <p:cNvGrpSpPr/>
+          <p:nvPr/>
+        </p:nvGrpSpPr>
+        <p:grpSpPr>
+          <a:xfrm>
+            <a:off x="1435205" y="4023360"/>
+            <a:ext cx="2567178" cy="2148840"/>
+            <a:chOff x="9073134" y="1691640"/>
+            <a:chExt cx="2567178" cy="2148840"/>
+          </a:xfrm>
+        </p:grpSpPr>
+        <p:sp>
+          <p:nvSpPr>
+            <p:cNvPr id="16" name="KPI NET PROFIT"/>
+            <p:cNvSpPr/>
+            <p:nvPr/>
+          </p:nvSpPr>
+          <p:spPr>
+            <a:xfrm>
+              <a:off x="9073134" y="1691640"/>
+              <a:ext cx="2567178" cy="2148840"/>
+            </a:xfrm>
+            <a:prstGeom prst="roundRect">
+              <a:avLst>
+                <a:gd name="adj" fmla="val 4255"/>
+              </a:avLst>
+            </a:prstGeom>
+            <a:solidFill>
+              <a:schemeClr val="accent1"/>
+            </a:solidFill>
+            <a:ln w="9525">
+              <a:solidFill>
+                <a:srgbClr val="E2E8F0"/>
+              </a:solidFill>
+              <a:prstDash val="solid"/>
+            </a:ln>
+            <a:effectLst>
+              <a:outerShdw blurRad="101600" dist="25400" dir="5400000" algn="bl" rotWithShape="0">
+                <a:srgbClr val="1B2A4A">
+                  <a:alpha val="10000"/>
+                </a:srgbClr>
+              </a:outerShdw>
+            </a:effectLst>
+          </p:spPr>
+        </p:sp>
+        <p:sp>
+          <p:nvSpPr>
+            <p:cNvPr id="17" name="Text 15"/>
+            <p:cNvSpPr txBox="1"/>
+            <p:nvPr/>
+          </p:nvSpPr>
+          <p:spPr>
+            <a:xfrm>
+              <a:off x="9347454" y="1965960"/>
+              <a:ext cx="2018538" cy="274320"/>
+            </a:xfrm>
+            <a:prstGeom prst="rect">
+              <a:avLst/>
+            </a:prstGeom>
+            <a:noFill/>
+            <a:ln/>
+          </p:spPr>
+          <p:txBody>
+            <a:bodyPr wrap="square" lIns="0" tIns="0" rIns="0" bIns="0" rtlCol="0" anchor="ctr"/>
+            <a:lstStyle/>
+            <a:p>
+              <a:pPr marL="0" indent="0">
+                <a:buNone/>
+              </a:pPr>
+              <a:r>
+                <a:rPr lang="en-US" sz="1200" b="1" kern="0" spc="200" dirty="0">
+                  <a:solidFill>
+                    <a:schemeClr val="bg2"/>
+                  </a:solidFill>
+                </a:rPr>
+                <a:t>NET PROFIT</a:t>
+              </a:r>
+              <a:endParaRPr lang="en-US" sz="1200" dirty="0"/>
+            </a:p>
+          </p:txBody>
+        </p:sp>
+        <p:sp>
+          <p:nvSpPr>
+            <p:cNvPr id="18" name="Text 16"/>
+            <p:cNvSpPr txBox="1"/>
+            <p:nvPr/>
+          </p:nvSpPr>
+          <p:spPr>
+            <a:xfrm>
+              <a:off x="9347454" y="2377440"/>
+              <a:ext cx="2018538" cy="822960"/>
+            </a:xfrm>
+            <a:prstGeom prst="rect">
+              <a:avLst/>
+            </a:prstGeom>
+            <a:noFill/>
+            <a:ln/>
+          </p:spPr>
+          <p:txBody>
+            <a:bodyPr wrap="square" lIns="0" tIns="0" rIns="0" bIns="0" rtlCol="0" anchor="ctr"/>
+            <a:lstStyle/>
+            <a:p>
+              <a:pPr marL="0" indent="0">
+                <a:buNone/>
+              </a:pPr>
+              <a:r>
+                <a:rPr lang="en-US" sz="3800" b="1" dirty="0">
+                  <a:solidFill>
+                    <a:schemeClr val="bg2"/>
+                  </a:solidFill>
+                  <a:latin typeface="Arial" pitchFamily="34" charset="0"/>
+                  <a:ea typeface="Arial" pitchFamily="34" charset="-122"/>
+                  <a:cs typeface="Arial" pitchFamily="34" charset="-120"/>
+                </a:rPr>
+                <a:t>$1.47M</a:t>
+              </a:r>
+              <a:endParaRPr lang="en-US" sz="3800" dirty="0"/>
+            </a:p>
+          </p:txBody>
+        </p:sp>
+        <p:sp>
+          <p:nvSpPr>
+            <p:cNvPr id="19" name="Text 17"/>
+            <p:cNvSpPr txBox="1"/>
+            <p:nvPr/>
+          </p:nvSpPr>
+          <p:spPr>
+            <a:xfrm>
+              <a:off x="9347454" y="3246120"/>
+              <a:ext cx="2018538" cy="320040"/>
+            </a:xfrm>
+            <a:prstGeom prst="rect">
+              <a:avLst/>
+            </a:prstGeom>
+            <a:noFill/>
+            <a:ln/>
+          </p:spPr>
+          <p:txBody>
+            <a:bodyPr wrap="square" lIns="0" tIns="0" rIns="0" bIns="0" rtlCol="0" anchor="ctr"/>
+            <a:lstStyle/>
+            <a:p>
+              <a:pPr marL="0" indent="0">
+                <a:buNone/>
+              </a:pPr>
+              <a:r>
+                <a:rPr lang="en-US" sz="1400" dirty="0">
+                  <a:solidFill>
+                    <a:schemeClr val="bg2"/>
+                  </a:solidFill>
+                </a:rPr>
+                <a:t>After product costs</a:t>
+              </a:r>
+              <a:endParaRPr lang="en-US" sz="1400" dirty="0"/>
+            </a:p>
+          </p:txBody>
+        </p:sp>
+      </p:grpSp>
+      <p:grpSp>
+        <p:nvGrpSpPr>
+          <p:cNvPr id="33" name="Group 32">
+            <a:extLst>
+              <a:ext uri="{FF2B5EF4-FFF2-40B4-BE49-F238E27FC236}">
+                <a16:creationId xmlns:a16="http://schemas.microsoft.com/office/drawing/2014/main" id="{B2D5602D-D57D-4CCE-835A-570E94498CB7}"/>
+              </a:ext>
+            </a:extLst>
+          </p:cNvPr>
+          <p:cNvGrpSpPr/>
+          <p:nvPr/>
+        </p:nvGrpSpPr>
+        <p:grpSpPr>
+          <a:xfrm>
+            <a:off x="4337303" y="4114800"/>
+            <a:ext cx="5348075" cy="2011680"/>
             <a:chOff x="548640" y="4114800"/>
             <a:chExt cx="3514344" cy="2011680"/>
           </a:xfrm>
@@ -5486,7 +5942,7 @@
                   <a:schemeClr val="tx1"/>
                 </a:solidFill>
               </a:rPr>
-              <a:t>Tablets</a:t>
+              <a:t>Tables</a:t>
             </a:r>
             <a:endParaRPr lang="en-US" sz="1600" dirty="0"/>
           </a:p>
@@ -6102,6 +6558,782 @@
 
 <file path=ppt/slides/slide4.xml><?xml version="1.0" encoding="utf-8"?>
 <p:sld xmlns:a="http://schemas.openxmlformats.org/drawingml/2006/main" xmlns:r="http://schemas.openxmlformats.org/officeDocument/2006/relationships" xmlns:p="http://schemas.openxmlformats.org/presentationml/2006/main">
+  <p:cSld name="Slide 4">
+    <p:spTree>
+      <p:nvGrpSpPr>
+        <p:cNvPr id="1" name=""/>
+        <p:cNvGrpSpPr/>
+        <p:nvPr/>
+      </p:nvGrpSpPr>
+      <p:grpSpPr>
+        <a:xfrm>
+          <a:off x="0" y="0"/>
+          <a:ext cx="0" cy="0"/>
+          <a:chOff x="0" y="0"/>
+          <a:chExt cx="0" cy="0"/>
+        </a:xfrm>
+      </p:grpSpPr>
+      <p:sp>
+        <p:nvSpPr>
+          <p:cNvPr id="2" name="Text 1"/>
+          <p:cNvSpPr>
+            <a:spLocks noGrp="1"/>
+          </p:cNvSpPr>
+          <p:nvPr>
+            <p:ph type="title" idx="101" hasCustomPrompt="1"/>
+          </p:nvPr>
+        </p:nvSpPr>
+        <p:spPr>
+          <a:xfrm>
+            <a:off x="548640" y="365760"/>
+            <a:ext cx="11091672" cy="685800"/>
+          </a:xfrm>
+          <a:prstGeom prst="rect">
+            <a:avLst/>
+          </a:prstGeom>
+          <a:noFill/>
+          <a:ln/>
+        </p:spPr>
+        <p:txBody>
+          <a:bodyPr wrap="square" lIns="0" tIns="0" rIns="0" bIns="0" rtlCol="0" anchor="ctr"/>
+          <a:lstStyle/>
+          <a:p>
+            <a:pPr marL="0" indent="0" algn="l">
+              <a:buNone/>
+            </a:pPr>
+            <a:r>
+              <a:rPr lang="en-US" sz="3400" b="1" dirty="0">
+                <a:solidFill>
+                  <a:schemeClr val="tx1"/>
+                </a:solidFill>
+              </a:rPr>
+              <a:t>Geographic Concentration &amp; Regional Footprint</a:t>
+            </a:r>
+            <a:endParaRPr lang="en-US" sz="3400" dirty="0"/>
+          </a:p>
+        </p:txBody>
+      </p:sp>
+      <p:sp>
+        <p:nvSpPr>
+          <p:cNvPr id="3" name="Subtitle"/>
+          <p:cNvSpPr txBox="1"/>
+          <p:nvPr/>
+        </p:nvSpPr>
+        <p:spPr>
+          <a:xfrm>
+            <a:off x="548640" y="1051560"/>
+            <a:ext cx="11091672" cy="411480"/>
+          </a:xfrm>
+          <a:prstGeom prst="rect">
+            <a:avLst/>
+          </a:prstGeom>
+          <a:noFill/>
+          <a:ln/>
+        </p:spPr>
+        <p:txBody>
+          <a:bodyPr wrap="square" lIns="0" tIns="0" rIns="0" bIns="0" rtlCol="0" anchor="ctr"/>
+          <a:lstStyle/>
+          <a:p>
+            <a:pPr marL="0" indent="0">
+              <a:buNone/>
+            </a:pPr>
+            <a:r>
+              <a:rPr lang="en-US" sz="1600" dirty="0">
+                <a:solidFill>
+                  <a:schemeClr val="tx2"/>
+                </a:solidFill>
+              </a:rPr>
+              <a:t>EU - Central is the largest single market; four macro-markets each contribute 19-24% of sales</a:t>
+            </a:r>
+            <a:endParaRPr lang="en-US" sz="1600" dirty="0"/>
+          </a:p>
+        </p:txBody>
+      </p:sp>
+      <p:sp>
+        <p:nvSpPr>
+          <p:cNvPr id="4" name="Regional chart card"/>
+          <p:cNvSpPr/>
+          <p:nvPr/>
+        </p:nvSpPr>
+        <p:spPr>
+          <a:xfrm>
+            <a:off x="548640" y="1645920"/>
+            <a:ext cx="6766560" cy="4572000"/>
+          </a:xfrm>
+          <a:prstGeom prst="roundRect">
+            <a:avLst>
+              <a:gd name="adj" fmla="val 2000"/>
+            </a:avLst>
+          </a:prstGeom>
+          <a:solidFill>
+            <a:schemeClr val="bg2"/>
+          </a:solidFill>
+          <a:ln w="9525">
+            <a:solidFill>
+              <a:srgbClr val="E2E8F0"/>
+            </a:solidFill>
+            <a:prstDash val="solid"/>
+          </a:ln>
+          <a:effectLst>
+            <a:outerShdw blurRad="101600" dist="25400" dir="5400000" algn="bl" rotWithShape="0">
+              <a:srgbClr val="1B2A4A">
+                <a:alpha val="10000"/>
+              </a:srgbClr>
+            </a:outerShdw>
+          </a:effectLst>
+        </p:spPr>
+      </p:sp>
+      <p:graphicFrame>
+        <p:nvGraphicFramePr>
+          <p:cNvPr id="5" name="Chart 0"/>
+          <p:cNvGraphicFramePr/>
+          <p:nvPr/>
+        </p:nvGraphicFramePr>
+        <p:xfrm>
+          <a:off x="685800" y="1737360"/>
+          <a:ext cx="6492240" cy="4389120"/>
+        </p:xfrm>
+        <a:graphic>
+          <a:graphicData uri="http://schemas.openxmlformats.org/drawingml/2006/chart">
+            <c:chart xmlns:c="http://schemas.openxmlformats.org/drawingml/2006/chart" xmlns:r="http://schemas.openxmlformats.org/officeDocument/2006/relationships" r:id="rId3"/>
+          </a:graphicData>
+        </a:graphic>
+      </p:graphicFrame>
+      <p:sp>
+        <p:nvSpPr>
+          <p:cNvPr id="6" name="Region block SCALE LEADER"/>
+          <p:cNvSpPr/>
+          <p:nvPr/>
+        </p:nvSpPr>
+        <p:spPr>
+          <a:xfrm>
+            <a:off x="7589520" y="1645920"/>
+            <a:ext cx="4050792" cy="1005840"/>
+          </a:xfrm>
+          <a:prstGeom prst="roundRect">
+            <a:avLst>
+              <a:gd name="adj" fmla="val 9091"/>
+            </a:avLst>
+          </a:prstGeom>
+          <a:solidFill>
+            <a:schemeClr val="bg2"/>
+          </a:solidFill>
+          <a:ln w="9525">
+            <a:solidFill>
+              <a:srgbClr val="E2E8F0"/>
+            </a:solidFill>
+            <a:prstDash val="solid"/>
+          </a:ln>
+          <a:effectLst>
+            <a:outerShdw blurRad="101600" dist="25400" dir="5400000" algn="bl" rotWithShape="0">
+              <a:srgbClr val="1B2A4A">
+                <a:alpha val="10000"/>
+              </a:srgbClr>
+            </a:outerShdw>
+          </a:effectLst>
+        </p:spPr>
+      </p:sp>
+      <p:sp>
+        <p:nvSpPr>
+          <p:cNvPr id="7" name="Text 4"/>
+          <p:cNvSpPr txBox="1"/>
+          <p:nvPr/>
+        </p:nvSpPr>
+        <p:spPr>
+          <a:xfrm>
+            <a:off x="7818120" y="1755648"/>
+            <a:ext cx="3593592" cy="228600"/>
+          </a:xfrm>
+          <a:prstGeom prst="rect">
+            <a:avLst/>
+          </a:prstGeom>
+          <a:noFill/>
+          <a:ln/>
+        </p:spPr>
+        <p:txBody>
+          <a:bodyPr wrap="square" lIns="0" tIns="0" rIns="0" bIns="0" rtlCol="0" anchor="ctr"/>
+          <a:lstStyle/>
+          <a:p>
+            <a:pPr marL="0" indent="0">
+              <a:buNone/>
+            </a:pPr>
+            <a:r>
+              <a:rPr lang="en-US" sz="1100" b="1" kern="0" spc="200" dirty="0">
+                <a:solidFill>
+                  <a:schemeClr val="accent6"/>
+                </a:solidFill>
+              </a:rPr>
+              <a:t>SCALE LEADER</a:t>
+            </a:r>
+            <a:endParaRPr lang="en-US" sz="1100" dirty="0"/>
+          </a:p>
+        </p:txBody>
+      </p:sp>
+      <p:sp>
+        <p:nvSpPr>
+          <p:cNvPr id="8" name="Text 5"/>
+          <p:cNvSpPr txBox="1"/>
+          <p:nvPr/>
+        </p:nvSpPr>
+        <p:spPr>
+          <a:xfrm>
+            <a:off x="7818120" y="1993392"/>
+            <a:ext cx="3593592" cy="365760"/>
+          </a:xfrm>
+          <a:prstGeom prst="rect">
+            <a:avLst/>
+          </a:prstGeom>
+          <a:noFill/>
+          <a:ln/>
+        </p:spPr>
+        <p:txBody>
+          <a:bodyPr wrap="square" lIns="0" tIns="0" rIns="0" bIns="0" rtlCol="0" anchor="ctr"/>
+          <a:lstStyle/>
+          <a:p>
+            <a:pPr marL="0" indent="0">
+              <a:buNone/>
+            </a:pPr>
+            <a:r>
+              <a:rPr lang="en-US" sz="2200" b="1" dirty="0">
+                <a:solidFill>
+                  <a:schemeClr val="accent1"/>
+                </a:solidFill>
+                <a:latin typeface="Arial" pitchFamily="34" charset="0"/>
+                <a:ea typeface="Arial" pitchFamily="34" charset="-122"/>
+                <a:cs typeface="Arial" pitchFamily="34" charset="-120"/>
+              </a:rPr>
+              <a:t>EU - Central</a:t>
+            </a:r>
+            <a:endParaRPr lang="en-US" sz="2200" dirty="0"/>
+          </a:p>
+        </p:txBody>
+      </p:sp>
+      <p:sp>
+        <p:nvSpPr>
+          <p:cNvPr id="9" name="Text 6"/>
+          <p:cNvSpPr txBox="1"/>
+          <p:nvPr/>
+        </p:nvSpPr>
+        <p:spPr>
+          <a:xfrm>
+            <a:off x="7818120" y="2359152"/>
+            <a:ext cx="3593592" cy="228600"/>
+          </a:xfrm>
+          <a:prstGeom prst="rect">
+            <a:avLst/>
+          </a:prstGeom>
+          <a:noFill/>
+          <a:ln/>
+        </p:spPr>
+        <p:txBody>
+          <a:bodyPr wrap="square" lIns="0" tIns="0" rIns="0" bIns="0" rtlCol="0" anchor="t"/>
+          <a:lstStyle/>
+          <a:p>
+            <a:pPr marL="0" indent="0">
+              <a:buNone/>
+            </a:pPr>
+            <a:r>
+              <a:rPr lang="en-US" sz="1200" dirty="0">
+                <a:solidFill>
+                  <a:schemeClr val="tx2"/>
+                </a:solidFill>
+              </a:rPr>
+              <a:t>14.0% of sales ($1.76M), margin 11.4%</a:t>
+            </a:r>
+            <a:endParaRPr lang="en-US" sz="1200" dirty="0"/>
+          </a:p>
+        </p:txBody>
+      </p:sp>
+      <p:sp>
+        <p:nvSpPr>
+          <p:cNvPr id="10" name="Region block MACRO-MARKET MIX"/>
+          <p:cNvSpPr/>
+          <p:nvPr/>
+        </p:nvSpPr>
+        <p:spPr>
+          <a:xfrm>
+            <a:off x="7589520" y="2834640"/>
+            <a:ext cx="4050792" cy="1005840"/>
+          </a:xfrm>
+          <a:prstGeom prst="roundRect">
+            <a:avLst>
+              <a:gd name="adj" fmla="val 9091"/>
+            </a:avLst>
+          </a:prstGeom>
+          <a:solidFill>
+            <a:schemeClr val="bg2"/>
+          </a:solidFill>
+          <a:ln w="9525">
+            <a:solidFill>
+              <a:srgbClr val="E2E8F0"/>
+            </a:solidFill>
+            <a:prstDash val="solid"/>
+          </a:ln>
+          <a:effectLst>
+            <a:outerShdw blurRad="101600" dist="25400" dir="5400000" algn="bl" rotWithShape="0">
+              <a:srgbClr val="1B2A4A">
+                <a:alpha val="10000"/>
+              </a:srgbClr>
+            </a:outerShdw>
+          </a:effectLst>
+        </p:spPr>
+      </p:sp>
+      <p:sp>
+        <p:nvSpPr>
+          <p:cNvPr id="11" name="Text 8"/>
+          <p:cNvSpPr txBox="1"/>
+          <p:nvPr/>
+        </p:nvSpPr>
+        <p:spPr>
+          <a:xfrm>
+            <a:off x="7818120" y="2944368"/>
+            <a:ext cx="3593592" cy="228600"/>
+          </a:xfrm>
+          <a:prstGeom prst="rect">
+            <a:avLst/>
+          </a:prstGeom>
+          <a:noFill/>
+          <a:ln/>
+        </p:spPr>
+        <p:txBody>
+          <a:bodyPr wrap="square" lIns="0" tIns="0" rIns="0" bIns="0" rtlCol="0" anchor="ctr"/>
+          <a:lstStyle/>
+          <a:p>
+            <a:pPr marL="0" indent="0">
+              <a:buNone/>
+            </a:pPr>
+            <a:r>
+              <a:rPr lang="en-US" sz="1100" b="1" kern="0" spc="200" dirty="0">
+                <a:solidFill>
+                  <a:schemeClr val="accent6"/>
+                </a:solidFill>
+              </a:rPr>
+              <a:t>MACRO-MARKET MIX</a:t>
+            </a:r>
+            <a:endParaRPr lang="en-US" sz="1100" dirty="0"/>
+          </a:p>
+        </p:txBody>
+      </p:sp>
+      <p:sp>
+        <p:nvSpPr>
+          <p:cNvPr id="12" name="Text 9"/>
+          <p:cNvSpPr txBox="1"/>
+          <p:nvPr/>
+        </p:nvSpPr>
+        <p:spPr>
+          <a:xfrm>
+            <a:off x="7818120" y="3182112"/>
+            <a:ext cx="3593592" cy="365760"/>
+          </a:xfrm>
+          <a:prstGeom prst="rect">
+            <a:avLst/>
+          </a:prstGeom>
+          <a:noFill/>
+          <a:ln/>
+        </p:spPr>
+        <p:txBody>
+          <a:bodyPr wrap="square" lIns="0" tIns="0" rIns="0" bIns="0" rtlCol="0" anchor="ctr"/>
+          <a:lstStyle/>
+          <a:p>
+            <a:pPr marL="0" indent="0">
+              <a:buNone/>
+            </a:pPr>
+            <a:r>
+              <a:rPr lang="en-US" sz="2200" b="1" dirty="0">
+                <a:solidFill>
+                  <a:schemeClr val="tx1"/>
+                </a:solidFill>
+                <a:latin typeface="Arial" pitchFamily="34" charset="0"/>
+                <a:ea typeface="Arial" pitchFamily="34" charset="-122"/>
+                <a:cs typeface="Arial" pitchFamily="34" charset="-120"/>
+              </a:rPr>
+              <a:t>EU 23.7%</a:t>
+            </a:r>
+            <a:endParaRPr lang="en-US" sz="2200" dirty="0"/>
+          </a:p>
+        </p:txBody>
+      </p:sp>
+      <p:sp>
+        <p:nvSpPr>
+          <p:cNvPr id="13" name="Text 10"/>
+          <p:cNvSpPr txBox="1"/>
+          <p:nvPr/>
+        </p:nvSpPr>
+        <p:spPr>
+          <a:xfrm>
+            <a:off x="7818120" y="3547872"/>
+            <a:ext cx="3593592" cy="228600"/>
+          </a:xfrm>
+          <a:prstGeom prst="rect">
+            <a:avLst/>
+          </a:prstGeom>
+          <a:noFill/>
+          <a:ln/>
+        </p:spPr>
+        <p:txBody>
+          <a:bodyPr wrap="square" lIns="0" tIns="0" rIns="0" bIns="0" rtlCol="0" anchor="t"/>
+          <a:lstStyle/>
+          <a:p>
+            <a:pPr marL="0" indent="0">
+              <a:buNone/>
+            </a:pPr>
+            <a:r>
+              <a:rPr lang="en-US" sz="1200" dirty="0">
+                <a:solidFill>
+                  <a:schemeClr val="tx2"/>
+                </a:solidFill>
+              </a:rPr>
+              <a:t>US 22.4%, APAC 21.9%, LATAM 18.9%</a:t>
+            </a:r>
+            <a:endParaRPr lang="en-US" sz="1200" dirty="0"/>
+          </a:p>
+        </p:txBody>
+      </p:sp>
+      <p:sp>
+        <p:nvSpPr>
+          <p:cNvPr id="14" name="Region block MARGIN LEADERS"/>
+          <p:cNvSpPr/>
+          <p:nvPr/>
+        </p:nvSpPr>
+        <p:spPr>
+          <a:xfrm>
+            <a:off x="7589520" y="4023360"/>
+            <a:ext cx="4050792" cy="1005840"/>
+          </a:xfrm>
+          <a:prstGeom prst="roundRect">
+            <a:avLst>
+              <a:gd name="adj" fmla="val 9091"/>
+            </a:avLst>
+          </a:prstGeom>
+          <a:solidFill>
+            <a:schemeClr val="bg2"/>
+          </a:solidFill>
+          <a:ln w="9525">
+            <a:solidFill>
+              <a:srgbClr val="E2E8F0"/>
+            </a:solidFill>
+            <a:prstDash val="solid"/>
+          </a:ln>
+          <a:effectLst>
+            <a:outerShdw blurRad="101600" dist="25400" dir="5400000" algn="bl" rotWithShape="0">
+              <a:srgbClr val="1B2A4A">
+                <a:alpha val="10000"/>
+              </a:srgbClr>
+            </a:outerShdw>
+          </a:effectLst>
+        </p:spPr>
+      </p:sp>
+      <p:sp>
+        <p:nvSpPr>
+          <p:cNvPr id="15" name="Text 12"/>
+          <p:cNvSpPr txBox="1"/>
+          <p:nvPr/>
+        </p:nvSpPr>
+        <p:spPr>
+          <a:xfrm>
+            <a:off x="7818120" y="4133088"/>
+            <a:ext cx="3593592" cy="228600"/>
+          </a:xfrm>
+          <a:prstGeom prst="rect">
+            <a:avLst/>
+          </a:prstGeom>
+          <a:noFill/>
+          <a:ln/>
+        </p:spPr>
+        <p:txBody>
+          <a:bodyPr wrap="square" lIns="0" tIns="0" rIns="0" bIns="0" rtlCol="0" anchor="ctr"/>
+          <a:lstStyle/>
+          <a:p>
+            <a:pPr marL="0" indent="0">
+              <a:buNone/>
+            </a:pPr>
+            <a:r>
+              <a:rPr lang="en-US" sz="1100" b="1" kern="0" spc="200" dirty="0">
+                <a:solidFill>
+                  <a:schemeClr val="accent6"/>
+                </a:solidFill>
+              </a:rPr>
+              <a:t>MARGIN LEADERS</a:t>
+            </a:r>
+            <a:endParaRPr lang="en-US" sz="1100" dirty="0"/>
+          </a:p>
+        </p:txBody>
+      </p:sp>
+      <p:sp>
+        <p:nvSpPr>
+          <p:cNvPr id="16" name="Text 13"/>
+          <p:cNvSpPr txBox="1"/>
+          <p:nvPr/>
+        </p:nvSpPr>
+        <p:spPr>
+          <a:xfrm>
+            <a:off x="7818120" y="4370832"/>
+            <a:ext cx="3593592" cy="365760"/>
+          </a:xfrm>
+          <a:prstGeom prst="rect">
+            <a:avLst/>
+          </a:prstGeom>
+          <a:noFill/>
+          <a:ln/>
+        </p:spPr>
+        <p:txBody>
+          <a:bodyPr wrap="square" lIns="0" tIns="0" rIns="0" bIns="0" rtlCol="0" anchor="ctr"/>
+          <a:lstStyle/>
+          <a:p>
+            <a:pPr marL="0" indent="0">
+              <a:buNone/>
+            </a:pPr>
+            <a:r>
+              <a:rPr lang="en-US" sz="2200" b="1" dirty="0">
+                <a:solidFill>
+                  <a:schemeClr val="accent1"/>
+                </a:solidFill>
+                <a:latin typeface="Arial" pitchFamily="34" charset="0"/>
+                <a:ea typeface="Arial" pitchFamily="34" charset="-122"/>
+                <a:cs typeface="Arial" pitchFamily="34" charset="-120"/>
+              </a:rPr>
+              <a:t>EU - North 13.6%</a:t>
+            </a:r>
+            <a:endParaRPr lang="en-US" sz="2200" dirty="0"/>
+          </a:p>
+        </p:txBody>
+      </p:sp>
+      <p:sp>
+        <p:nvSpPr>
+          <p:cNvPr id="17" name="Text 14"/>
+          <p:cNvSpPr txBox="1"/>
+          <p:nvPr/>
+        </p:nvSpPr>
+        <p:spPr>
+          <a:xfrm>
+            <a:off x="7818120" y="4736592"/>
+            <a:ext cx="3593592" cy="228600"/>
+          </a:xfrm>
+          <a:prstGeom prst="rect">
+            <a:avLst/>
+          </a:prstGeom>
+          <a:noFill/>
+          <a:ln/>
+        </p:spPr>
+        <p:txBody>
+          <a:bodyPr wrap="square" lIns="0" tIns="0" rIns="0" bIns="0" rtlCol="0" anchor="t"/>
+          <a:lstStyle/>
+          <a:p>
+            <a:pPr marL="0" indent="0">
+              <a:buNone/>
+            </a:pPr>
+            <a:r>
+              <a:rPr lang="en-US" sz="1200" dirty="0">
+                <a:solidFill>
+                  <a:schemeClr val="tx2"/>
+                </a:solidFill>
+              </a:rPr>
+              <a:t>APAC - Oceania 13.4%, US - East 13.1%</a:t>
+            </a:r>
+            <a:endParaRPr lang="en-US" sz="1200" dirty="0"/>
+          </a:p>
+        </p:txBody>
+      </p:sp>
+      <p:sp>
+        <p:nvSpPr>
+          <p:cNvPr id="18" name="Region block MARGIN LAGGARDS"/>
+          <p:cNvSpPr/>
+          <p:nvPr/>
+        </p:nvSpPr>
+        <p:spPr>
+          <a:xfrm>
+            <a:off x="7589520" y="5212080"/>
+            <a:ext cx="4050792" cy="1005840"/>
+          </a:xfrm>
+          <a:prstGeom prst="roundRect">
+            <a:avLst>
+              <a:gd name="adj" fmla="val 9091"/>
+            </a:avLst>
+          </a:prstGeom>
+          <a:solidFill>
+            <a:schemeClr val="bg2"/>
+          </a:solidFill>
+          <a:ln w="9525">
+            <a:solidFill>
+              <a:srgbClr val="E2E8F0"/>
+            </a:solidFill>
+            <a:prstDash val="solid"/>
+          </a:ln>
+          <a:effectLst>
+            <a:outerShdw blurRad="101600" dist="25400" dir="5400000" algn="bl" rotWithShape="0">
+              <a:srgbClr val="1B2A4A">
+                <a:alpha val="10000"/>
+              </a:srgbClr>
+            </a:outerShdw>
+          </a:effectLst>
+        </p:spPr>
+      </p:sp>
+      <p:sp>
+        <p:nvSpPr>
+          <p:cNvPr id="19" name="Text 16"/>
+          <p:cNvSpPr txBox="1"/>
+          <p:nvPr/>
+        </p:nvSpPr>
+        <p:spPr>
+          <a:xfrm>
+            <a:off x="7818120" y="5321808"/>
+            <a:ext cx="3593592" cy="228600"/>
+          </a:xfrm>
+          <a:prstGeom prst="rect">
+            <a:avLst/>
+          </a:prstGeom>
+          <a:noFill/>
+          <a:ln/>
+        </p:spPr>
+        <p:txBody>
+          <a:bodyPr wrap="square" lIns="0" tIns="0" rIns="0" bIns="0" rtlCol="0" anchor="ctr"/>
+          <a:lstStyle/>
+          <a:p>
+            <a:pPr marL="0" indent="0">
+              <a:buNone/>
+            </a:pPr>
+            <a:r>
+              <a:rPr lang="en-US" sz="1100" b="1" kern="0" spc="200" dirty="0">
+                <a:solidFill>
+                  <a:schemeClr val="accent6"/>
+                </a:solidFill>
+              </a:rPr>
+              <a:t>MARGIN LAGGARDS</a:t>
+            </a:r>
+            <a:endParaRPr lang="en-US" sz="1100" dirty="0"/>
+          </a:p>
+        </p:txBody>
+      </p:sp>
+      <p:sp>
+        <p:nvSpPr>
+          <p:cNvPr id="20" name="Text 17"/>
+          <p:cNvSpPr txBox="1"/>
+          <p:nvPr/>
+        </p:nvSpPr>
+        <p:spPr>
+          <a:xfrm>
+            <a:off x="7818120" y="5559552"/>
+            <a:ext cx="3593592" cy="365760"/>
+          </a:xfrm>
+          <a:prstGeom prst="rect">
+            <a:avLst/>
+          </a:prstGeom>
+          <a:noFill/>
+          <a:ln/>
+        </p:spPr>
+        <p:txBody>
+          <a:bodyPr wrap="square" lIns="0" tIns="0" rIns="0" bIns="0" rtlCol="0" anchor="ctr"/>
+          <a:lstStyle/>
+          <a:p>
+            <a:pPr marL="0" indent="0">
+              <a:buNone/>
+            </a:pPr>
+            <a:r>
+              <a:rPr lang="en-US" sz="2200" b="1" dirty="0">
+                <a:solidFill>
+                  <a:schemeClr val="accent4"/>
+                </a:solidFill>
+                <a:latin typeface="Arial" pitchFamily="34" charset="0"/>
+                <a:ea typeface="Arial" pitchFamily="34" charset="-122"/>
+                <a:cs typeface="Arial" pitchFamily="34" charset="-120"/>
+              </a:rPr>
+              <a:t>EMEA 8.5%</a:t>
+            </a:r>
+            <a:endParaRPr lang="en-US" sz="2200" dirty="0"/>
+          </a:p>
+        </p:txBody>
+      </p:sp>
+      <p:sp>
+        <p:nvSpPr>
+          <p:cNvPr id="21" name="Text 18"/>
+          <p:cNvSpPr txBox="1"/>
+          <p:nvPr/>
+        </p:nvSpPr>
+        <p:spPr>
+          <a:xfrm>
+            <a:off x="7818120" y="5925312"/>
+            <a:ext cx="3593592" cy="228600"/>
+          </a:xfrm>
+          <a:prstGeom prst="rect">
+            <a:avLst/>
+          </a:prstGeom>
+          <a:noFill/>
+          <a:ln/>
+        </p:spPr>
+        <p:txBody>
+          <a:bodyPr wrap="square" lIns="0" tIns="0" rIns="0" bIns="0" rtlCol="0" anchor="t"/>
+          <a:lstStyle/>
+          <a:p>
+            <a:pPr marL="0" indent="0">
+              <a:buNone/>
+            </a:pPr>
+            <a:r>
+              <a:rPr lang="en-US" sz="1200" dirty="0">
+                <a:solidFill>
+                  <a:schemeClr val="tx2"/>
+                </a:solidFill>
+              </a:rPr>
+              <a:t>US - South 8.9%, Africa 9.7%</a:t>
+            </a:r>
+            <a:endParaRPr lang="en-US" sz="1200" dirty="0"/>
+          </a:p>
+        </p:txBody>
+      </p:sp>
+      <p:sp>
+        <p:nvSpPr>
+          <p:cNvPr id="25" name="Slide Number Placeholder 0"/>
+          <p:cNvSpPr>
+            <a:spLocks noGrp="1"/>
+          </p:cNvSpPr>
+          <p:nvPr>
+            <p:ph type="sldNum" sz="quarter" idx="4294967295"/>
+          </p:nvPr>
+        </p:nvSpPr>
+        <p:spPr>
+          <a:xfrm>
+            <a:off x="11064240" y="6400800"/>
+            <a:ext cx="548640" cy="274320"/>
+          </a:xfrm>
+          <a:prstGeom prst="rect">
+            <a:avLst/>
+          </a:prstGeom>
+          <a:extLst>
+            <a:ext uri="{C572A759-6A51-4108-AA02-DFA0A04FC94B}">
+              <ma14:wrappingTextBoxFlag xmlns:ma14="http://schemas.microsoft.com/office/mac/drawingml/2011/main" xmlns="" val="0"/>
+            </a:ext>
+          </a:extLst>
+        </p:spPr>
+        <p:txBody>
+          <a:bodyPr/>
+          <a:lstStyle>
+            <a:lvl1pPr>
+              <a:defRPr sz="1000">
+                <a:solidFill>
+                  <a:schemeClr val="tx2"/>
+                </a:solidFill>
+              </a:defRPr>
+            </a:lvl1pPr>
+          </a:lstStyle>
+          <a:p>
+            <a:pPr algn="r"/>
+            <a:fld id="{F7021451-1387-4CA6-816F-3879F97B5CBC}" type="slidenum">
+              <a:rPr lang="en-US" b="0"/>
+              <a:t>4</a:t>
+            </a:fld>
+            <a:endParaRPr lang="en-US"/>
+          </a:p>
+        </p:txBody>
+      </p:sp>
+    </p:spTree>
+  </p:cSld>
+  <p:clrMapOvr>
+    <a:masterClrMapping/>
+  </p:clrMapOvr>
+</p:sld>
+</file>
+
+<file path=ppt/slides/slide5.xml><?xml version="1.0" encoding="utf-8"?>
+<p:sld xmlns:a="http://schemas.openxmlformats.org/drawingml/2006/main" xmlns:r="http://schemas.openxmlformats.org/officeDocument/2006/relationships" xmlns:p="http://schemas.openxmlformats.org/presentationml/2006/main">
   <p:cSld name="Slide 5">
     <p:spTree>
       <p:nvGrpSpPr>
@@ -7250,7 +8482,7 @@
             <a:pPr algn="r"/>
             <a:fld id="{F7021451-1387-4CA6-816F-3879F97B5CBC}" type="slidenum">
               <a:rPr lang="en-US" b="0"/>
-              <a:t>4</a:t>
+              <a:t>5</a:t>
             </a:fld>
             <a:endParaRPr lang="en-US"/>
           </a:p>
@@ -7264,7 +8496,7 @@
 </p:sld>
 </file>
 
-<file path=ppt/slides/slide5.xml><?xml version="1.0" encoding="utf-8"?>
+<file path=ppt/slides/slide6.xml><?xml version="1.0" encoding="utf-8"?>
 <p:sld xmlns:a="http://schemas.openxmlformats.org/drawingml/2006/main" xmlns:r="http://schemas.openxmlformats.org/officeDocument/2006/relationships" xmlns:p="http://schemas.openxmlformats.org/presentationml/2006/main">
   <p:cSld name="Slide 6">
     <p:spTree>
@@ -10101,7 +11333,7 @@
             <a:pPr algn="r"/>
             <a:fld id="{F7021451-1387-4CA6-816F-3879F97B5CBC}" type="slidenum">
               <a:rPr lang="en-US" b="0"/>
-              <a:t>5</a:t>
+              <a:t>6</a:t>
             </a:fld>
             <a:endParaRPr lang="en-US"/>
           </a:p>
@@ -10115,7 +11347,7 @@
 </p:sld>
 </file>
 
-<file path=ppt/slides/slide6.xml><?xml version="1.0" encoding="utf-8"?>
+<file path=ppt/slides/slide7.xml><?xml version="1.0" encoding="utf-8"?>
 <p:sld xmlns:a="http://schemas.openxmlformats.org/drawingml/2006/main" xmlns:r="http://schemas.openxmlformats.org/officeDocument/2006/relationships" xmlns:p="http://schemas.openxmlformats.org/presentationml/2006/main">
   <p:cSld name="Slide 7">
     <p:spTree>
@@ -10729,6 +11961,179 @@
       </p:sp>
       <p:sp>
         <p:nvSpPr>
+          <p:cNvPr id="19" name="Action 4"/>
+          <p:cNvSpPr/>
+          <p:nvPr/>
+        </p:nvSpPr>
+        <p:spPr>
+          <a:xfrm>
+            <a:off x="6231636" y="4023360"/>
+            <a:ext cx="5408676" cy="2194560"/>
+          </a:xfrm>
+          <a:prstGeom prst="roundRect">
+            <a:avLst>
+              <a:gd name="adj" fmla="val 4167"/>
+            </a:avLst>
+          </a:prstGeom>
+          <a:solidFill>
+            <a:schemeClr val="bg2"/>
+          </a:solidFill>
+          <a:ln w="9525">
+            <a:solidFill>
+              <a:srgbClr val="E2E8F0"/>
+            </a:solidFill>
+            <a:prstDash val="solid"/>
+          </a:ln>
+          <a:effectLst>
+            <a:outerShdw blurRad="101600" dist="25400" dir="5400000" algn="bl" rotWithShape="0">
+              <a:srgbClr val="1B2A4A">
+                <a:alpha val="10000"/>
+              </a:srgbClr>
+            </a:outerShdw>
+          </a:effectLst>
+        </p:spPr>
+      </p:sp>
+      <p:sp>
+        <p:nvSpPr>
+          <p:cNvPr id="20" name="Number badge 4"/>
+          <p:cNvSpPr/>
+          <p:nvPr/>
+        </p:nvSpPr>
+        <p:spPr>
+          <a:xfrm>
+            <a:off x="6505956" y="4297680"/>
+            <a:ext cx="548640" cy="548640"/>
+          </a:xfrm>
+          <a:prstGeom prst="ellipse">
+            <a:avLst/>
+          </a:prstGeom>
+          <a:solidFill>
+            <a:schemeClr val="accent1"/>
+          </a:solidFill>
+          <a:ln w="12700">
+            <a:solidFill>
+              <a:schemeClr val="accent1"/>
+            </a:solidFill>
+            <a:prstDash val="solid"/>
+          </a:ln>
+        </p:spPr>
+      </p:sp>
+      <p:sp>
+        <p:nvSpPr>
+          <p:cNvPr id="21" name="Text 19"/>
+          <p:cNvSpPr txBox="1"/>
+          <p:nvPr/>
+        </p:nvSpPr>
+        <p:spPr>
+          <a:xfrm>
+            <a:off x="6505956" y="4297680"/>
+            <a:ext cx="548640" cy="548640"/>
+          </a:xfrm>
+          <a:prstGeom prst="rect">
+            <a:avLst/>
+          </a:prstGeom>
+          <a:noFill/>
+          <a:ln/>
+        </p:spPr>
+        <p:txBody>
+          <a:bodyPr wrap="square" lIns="0" tIns="0" rIns="0" bIns="0" rtlCol="0" anchor="ctr"/>
+          <a:lstStyle/>
+          <a:p>
+            <a:pPr marL="0" indent="0" algn="ctr">
+              <a:buNone/>
+            </a:pPr>
+            <a:r>
+              <a:rPr lang="en-US" sz="2200" b="1" dirty="0">
+                <a:solidFill>
+                  <a:schemeClr val="bg2"/>
+                </a:solidFill>
+                <a:latin typeface="Arial" pitchFamily="34" charset="0"/>
+                <a:ea typeface="Arial" pitchFamily="34" charset="-122"/>
+                <a:cs typeface="Arial" pitchFamily="34" charset="-120"/>
+              </a:rPr>
+              <a:t>4</a:t>
+            </a:r>
+            <a:endParaRPr lang="en-US" sz="2200" dirty="0"/>
+          </a:p>
+        </p:txBody>
+      </p:sp>
+      <p:sp>
+        <p:nvSpPr>
+          <p:cNvPr id="22" name="Text 20"/>
+          <p:cNvSpPr txBox="1"/>
+          <p:nvPr/>
+        </p:nvSpPr>
+        <p:spPr>
+          <a:xfrm>
+            <a:off x="7283196" y="4297680"/>
+            <a:ext cx="4082796" cy="548640"/>
+          </a:xfrm>
+          <a:prstGeom prst="rect">
+            <a:avLst/>
+          </a:prstGeom>
+          <a:noFill/>
+          <a:ln/>
+        </p:spPr>
+        <p:txBody>
+          <a:bodyPr wrap="square" lIns="0" tIns="0" rIns="0" bIns="0" rtlCol="0" anchor="ctr"/>
+          <a:lstStyle/>
+          <a:p>
+            <a:pPr marL="0" indent="0">
+              <a:buNone/>
+            </a:pPr>
+            <a:r>
+              <a:rPr lang="en-US" sz="2000" b="1" dirty="0">
+                <a:solidFill>
+                  <a:schemeClr val="tx1"/>
+                </a:solidFill>
+                <a:latin typeface="Arial" pitchFamily="34" charset="0"/>
+                <a:ea typeface="Arial" pitchFamily="34" charset="-122"/>
+                <a:cs typeface="Arial" pitchFamily="34" charset="-120"/>
+              </a:rPr>
+              <a:t>Double down on strongholds, fix laggards</a:t>
+            </a:r>
+            <a:endParaRPr lang="en-US" sz="2000" dirty="0"/>
+          </a:p>
+        </p:txBody>
+      </p:sp>
+      <p:sp>
+        <p:nvSpPr>
+          <p:cNvPr id="23" name="Text 21"/>
+          <p:cNvSpPr txBox="1"/>
+          <p:nvPr/>
+        </p:nvSpPr>
+        <p:spPr>
+          <a:xfrm>
+            <a:off x="6505956" y="5029200"/>
+            <a:ext cx="4860036" cy="1005840"/>
+          </a:xfrm>
+          <a:prstGeom prst="rect">
+            <a:avLst/>
+          </a:prstGeom>
+          <a:noFill/>
+          <a:ln/>
+        </p:spPr>
+        <p:txBody>
+          <a:bodyPr wrap="square" lIns="0" tIns="0" rIns="0" bIns="0" rtlCol="0" anchor="t"/>
+          <a:lstStyle/>
+          <a:p>
+            <a:pPr marL="0" indent="0">
+              <a:buNone/>
+            </a:pPr>
+            <a:r>
+              <a:rPr lang="en-US" sz="1600" dirty="0">
+                <a:solidFill>
+                  <a:schemeClr val="tx2"/>
+                </a:solidFill>
+              </a:rPr>
+              <a:t>Defend Central (24% of sales); lift EMEA and Caribbean (8.4%) toward the 11.6% company margin.</a:t>
+            </a:r>
+            <a:endParaRPr lang="en-US" sz="1600" dirty="0"/>
+          </a:p>
+        </p:txBody>
+      </p:sp>
+      <p:sp>
+        <p:nvSpPr>
           <p:cNvPr id="25" name="Slide Number Placeholder 0"/>
           <p:cNvSpPr>
             <a:spLocks noGrp="1"/>
@@ -10766,7 +12171,7 @@
             <a:pPr algn="r"/>
             <a:fld id="{F7021451-1387-4CA6-816F-3879F97B5CBC}" type="slidenum">
               <a:rPr lang="en-US" b="0"/>
-              <a:t>6</a:t>
+              <a:t>7</a:t>
             </a:fld>
             <a:endParaRPr lang="en-US"/>
           </a:p>

</xml_diff>